<commit_message>
Erklärvideos 00–07: Folien neu gebaut (Kontrastregel, echte Bilder), video_folien --pruefen in CI (M9 Task 214)
Kamera-Zone: Layouts merke/falle auf Video-Folien in der linken Inhaltsbreite; video_folien --pruefen läuft in npm test
(Workflow-Datei unverändert, GitHub Actions ruhen).

Co-Authored-By: Claude Opus 5.5 <noreply@anthropic.com>
Claude-Session: https://claude.ai/code/session_01JKXVQqFeKVmyQ9jfHw4db3
</commit_message>
<xml_diff>
--- a/materialien/Videos/00_Kryptos_Zeitreise/KR_Video_00_Kryptos_Zeitreise_Folien.pptx
+++ b/materialien/Videos/00_Kryptos_Zeitreise/KR_Video_00_Kryptos_Zeitreise_Folien.pptx
@@ -121,52 +121,52 @@
   <p:extLst>
     <p:ext uri="{521415D9-36F7-43E2-AB2F-B90AF26B5E84}">
       <p14:sectionLst xmlns:p14="http://schemas.microsoft.com/office/powerpoint/2010/main">
-        <p14:section name="Einstieg" id="{8972c991-477d-69a4-def8-7f17e343d9bf}">
+        <p14:section name="Einstieg" id="{546eaec6-0097-c333-2777-b401db5297e7}">
           <p14:sldIdLst>
             <p14:sldId id="256"/>
             <p14:sldId id="257"/>
           </p14:sldIdLst>
         </p14:section>
-        <p14:section name="Anmelden über InfoLabs" id="{8165b1c3-0423-f7d2-24d3-948ff7f016a2}">
+        <p14:section name="Anmelden über InfoLabs" id="{7b1fe01d-e478-f826-b2c3-f2890130d614}">
           <p14:sldIdLst>
             <p14:sldId id="258"/>
             <p14:sldId id="259"/>
           </p14:sldIdLst>
         </p14:section>
-        <p14:section name="Zeitleiste und Level" id="{6f2a5b33-9b05-86d6-96ed-a634afc041bf}">
+        <p14:section name="Zeitleiste und Level" id="{0ddaec43-a63c-97ad-4198-cdc4247030cf}">
           <p14:sldIdLst>
             <p14:sldId id="260"/>
             <p14:sldId id="261"/>
           </p14:sldIdLst>
         </p14:section>
-        <p14:section name="Punkte und Fallen" id="{dccd0ae2-e997-0bbb-8ed2-145f6976c800}">
+        <p14:section name="Punkte und Fallen" id="{1504397a-507d-2c01-fa4b-9e11db4b42df}">
           <p14:sldIdLst>
             <p14:sldId id="262"/>
             <p14:sldId id="263"/>
           </p14:sldIdLst>
         </p14:section>
-        <p14:section name="Boss, Training, Warm-up" id="{61d09ea3-4a30-34bf-58f3-f0b10e786751}">
+        <p14:section name="Boss, Training, Warm-up" id="{09da3bc5-8862-8dcf-4368-a62f455f5e19}">
           <p14:sldIdLst>
             <p14:sldId id="264"/>
           </p14:sldIdLst>
         </p14:section>
-        <p14:section name="Labor und Funkraum" id="{b9abed1b-6343-c3be-a19a-120c6dd9aae3}">
+        <p14:section name="Labor und Funkraum" id="{8913e366-a930-f1d9-70ad-fdbfc146dbee}">
           <p14:sldIdLst>
             <p14:sldId id="265"/>
           </p14:sldIdLst>
         </p14:section>
-        <p14:section name="Ränge und Artefakte" id="{9c8eec9b-757d-2fb3-d7cc-37cae7fd6378}">
+        <p14:section name="Ränge und Artefakte" id="{cfc9eb4f-6dd1-6d67-2e56-ac0fde7cab2f}">
           <p14:sldIdLst>
             <p14:sldId id="266"/>
           </p14:sldIdLst>
         </p14:section>
-        <p14:section name="Gastmodus" id="{ce34f104-37e5-10ed-9792-ce444b525d34}">
+        <p14:section name="Gastmodus" id="{061c7cf8-ac79-59ec-a8a1-c2680914e530}">
           <p14:sldIdLst>
             <p14:sldId id="267"/>
             <p14:sldId id="268"/>
           </p14:sldIdLst>
         </p14:section>
-        <p14:section name="Zusammenfassung" id="{346182a0-2411-dd83-543c-0480a67a44fe}">
+        <p14:section name="Zusammenfassung" id="{44efdc7e-ca92-e070-21ca-fd471a852dc3}">
           <p14:sldIdLst>
             <p14:sldId id="269"/>
             <p14:sldId id="270"/>
@@ -3183,79 +3183,33 @@
           </a:p>
         </p:txBody>
       </p:sp>
-      <p:sp>
-        <p:nvSpPr>
-          <p:cNvPr id="3" name="Bildplatzhalter"/>
-          <p:cNvSpPr/>
+      <p:pic>
+        <p:nvPicPr>
+          <p:cNvPr id="3" name="Image 0" descr="Links: Übersicht Kryptolabor mit Werkzeug-Kacheln (Chiffrierscheibe, Häufigkeits-Analysator, Substitutions-Werkbank, Vigenère-Werkbank, Bit-Lupe, Hash-Labor …). Rechts: Funkraum-Beameransicht auf Nachtblau – Teams als Knoten mit Namen aus der festen Liste (z. B. „Team Skytale“), Nachrichten als wandernde Punkte, Eve-Knoten rot umrandet.">    </p:cNvPr>
+          <p:cNvPicPr>
+            <a:picLocks noChangeAspect="1"/>
+          </p:cNvPicPr>
           <p:nvPr/>
-        </p:nvSpPr>
+        </p:nvPicPr>
+        <p:blipFill>
+          <a:blip r:embed="rId1"/>
+          <a:stretch>
+            <a:fillRect/>
+          </a:stretch>
+        </p:blipFill>
         <p:spPr>
           <a:xfrm>
             <a:off x="548640" y="1325880"/>
-            <a:ext cx="5003597" cy="2926080"/>
-          </a:xfrm>
-          <a:prstGeom prst="rect">
-            <a:avLst/>
-          </a:prstGeom>
-          <a:solidFill>
-            <a:srgbClr val="FFFFFF"/>
-          </a:solidFill>
-          <a:ln w="15875">
-            <a:solidFill>
-              <a:srgbClr val="4A4A55"/>
-            </a:solidFill>
-            <a:prstDash val="dash"/>
-          </a:ln>
-        </p:spPr>
-      </p:sp>
-      <p:sp>
-        <p:nvSpPr>
-          <p:cNvPr id="4" name="Text 2"/>
-          <p:cNvSpPr txBox="1"/>
-          <p:nvPr/>
-        </p:nvSpPr>
-        <p:spPr>
-          <a:xfrm>
-            <a:off x="822960" y="1600200"/>
-            <a:ext cx="4454957" cy="2377440"/>
-          </a:xfrm>
-          <a:prstGeom prst="rect">
-            <a:avLst/>
-          </a:prstGeom>
-          <a:noFill/>
-          <a:ln/>
-        </p:spPr>
-        <p:txBody>
-          <a:bodyPr wrap="square" lIns="0" tIns="0" rIns="0" bIns="0" rtlCol="0" anchor="ctr"/>
-          <a:lstStyle/>
-          <a:p>
-            <a:pPr algn="ctr" indent="0" marL="0">
-              <a:buNone/>
-            </a:pPr>
-            <a:r>
-              <a:rPr lang="en-US" sz="1400" b="1" spc="200" kern="0" dirty="0">
-                <a:solidFill>
-                  <a:srgbClr val="4A4A55"/>
-                </a:solidFill>
-              </a:rPr>
-              <a:t>BILD EINFÜGEN
-</a:t>
-            </a:r>
-            <a:r>
-              <a:rPr lang="en-US" sz="1400" dirty="0">
-                <a:solidFill>
-                  <a:srgbClr val="4A4A55"/>
-                </a:solidFill>
-              </a:rPr>
-              <a:t>Links: Übersicht Kryptolabor mit Werkzeug-Kacheln (Chiffrierscheibe, Häufigkeits-Analysator, Substitutions-Werkbank, Vigenère-Werkbank, Bit-Lupe, Hash-Labor …). Rechts: Funkraum-Beameransicht auf Nachtblau – Teams als Knoten mit Namen aus der festen Liste (z. B. „Team Skytale“), Nachrichten als wandernde Punkte, Eve-Knoten rot umrandet.</a:t>
-            </a:r>
-            <a:endParaRPr lang="en-US" sz="1400" dirty="0"/>
-          </a:p>
-        </p:txBody>
-      </p:sp>
-      <p:sp>
-        <p:nvSpPr>
-          <p:cNvPr id="5" name="Shape 3"/>
+            <a:ext cx="5003597" cy="2814523"/>
+          </a:xfrm>
+          <a:prstGeom prst="rect">
+            <a:avLst/>
+          </a:prstGeom>
+        </p:spPr>
+      </p:pic>
+      <p:sp>
+        <p:nvSpPr>
+          <p:cNvPr id="4" name="Shape 1"/>
           <p:cNvSpPr/>
           <p:nvPr/>
         </p:nvSpPr>
@@ -3282,7 +3236,7 @@
       </p:sp>
       <p:sp>
         <p:nvSpPr>
-          <p:cNvPr id="6" name="Text 4"/>
+          <p:cNvPr id="5" name="Text 2"/>
           <p:cNvSpPr txBox="1"/>
           <p:nvPr/>
         </p:nvSpPr>
@@ -3318,7 +3272,7 @@
       </p:sp>
       <p:sp>
         <p:nvSpPr>
-          <p:cNvPr id="7" name="Text 5"/>
+          <p:cNvPr id="6" name="Text 3"/>
           <p:cNvSpPr txBox="1"/>
           <p:nvPr/>
         </p:nvSpPr>
@@ -3354,7 +3308,7 @@
       </p:sp>
       <p:sp>
         <p:nvSpPr>
-          <p:cNvPr id="8" name="Text 6"/>
+          <p:cNvPr id="7" name="Text 4"/>
           <p:cNvSpPr txBox="1"/>
           <p:nvPr/>
         </p:nvSpPr>
@@ -3390,7 +3344,7 @@
       </p:sp>
       <p:sp>
         <p:nvSpPr>
-          <p:cNvPr id="9" name="Text 7"/>
+          <p:cNvPr id="8" name="Text 5"/>
           <p:cNvSpPr txBox="1"/>
           <p:nvPr/>
         </p:nvSpPr>
@@ -3535,79 +3489,33 @@
           </a:p>
         </p:txBody>
       </p:sp>
-      <p:sp>
-        <p:nvSpPr>
-          <p:cNvPr id="3" name="Bildplatzhalter"/>
-          <p:cNvSpPr/>
+      <p:pic>
+        <p:nvPicPr>
+          <p:cNvPr id="3" name="Image 0" descr="Screenshot Profil: Rang-Abzeichen, Punkte, Reihe der sieben Artefakte (Skytale bis Chronoskop-Kern, gesperrte als Umriss), Abzeichen, Radar „Deine Fallen“ P1–P10.">    </p:cNvPr>
+          <p:cNvPicPr>
+            <a:picLocks noChangeAspect="1"/>
+          </p:cNvPicPr>
           <p:nvPr/>
-        </p:nvSpPr>
+        </p:nvPicPr>
+        <p:blipFill>
+          <a:blip r:embed="rId1"/>
+          <a:stretch>
+            <a:fillRect/>
+          </a:stretch>
+        </p:blipFill>
         <p:spPr>
           <a:xfrm>
             <a:off x="548640" y="1325880"/>
-            <a:ext cx="5003597" cy="2926080"/>
-          </a:xfrm>
-          <a:prstGeom prst="rect">
-            <a:avLst/>
-          </a:prstGeom>
-          <a:solidFill>
-            <a:srgbClr val="FFFFFF"/>
-          </a:solidFill>
-          <a:ln w="15875">
-            <a:solidFill>
-              <a:srgbClr val="4A4A55"/>
-            </a:solidFill>
-            <a:prstDash val="dash"/>
-          </a:ln>
-        </p:spPr>
-      </p:sp>
-      <p:sp>
-        <p:nvSpPr>
-          <p:cNvPr id="4" name="Text 2"/>
-          <p:cNvSpPr txBox="1"/>
-          <p:nvPr/>
-        </p:nvSpPr>
-        <p:spPr>
-          <a:xfrm>
-            <a:off x="822960" y="1600200"/>
-            <a:ext cx="4454957" cy="2377440"/>
-          </a:xfrm>
-          <a:prstGeom prst="rect">
-            <a:avLst/>
-          </a:prstGeom>
-          <a:noFill/>
-          <a:ln/>
-        </p:spPr>
-        <p:txBody>
-          <a:bodyPr wrap="square" lIns="0" tIns="0" rIns="0" bIns="0" rtlCol="0" anchor="ctr"/>
-          <a:lstStyle/>
-          <a:p>
-            <a:pPr algn="ctr" indent="0" marL="0">
-              <a:buNone/>
-            </a:pPr>
-            <a:r>
-              <a:rPr lang="en-US" sz="1400" b="1" spc="200" kern="0" dirty="0">
-                <a:solidFill>
-                  <a:srgbClr val="4A4A55"/>
-                </a:solidFill>
-              </a:rPr>
-              <a:t>BILD EINFÜGEN
-</a:t>
-            </a:r>
-            <a:r>
-              <a:rPr lang="en-US" sz="1400" dirty="0">
-                <a:solidFill>
-                  <a:srgbClr val="4A4A55"/>
-                </a:solidFill>
-              </a:rPr>
-              <a:t>Screenshot Profil: Rang-Abzeichen, Punkte, Reihe der sieben Artefakte (Skytale bis Chronoskop-Kern, gesperrte als Umriss), Abzeichen, Radar „Deine Fallen“ P1–P10.</a:t>
-            </a:r>
-            <a:endParaRPr lang="en-US" sz="1400" dirty="0"/>
-          </a:p>
-        </p:txBody>
-      </p:sp>
-      <p:sp>
-        <p:nvSpPr>
-          <p:cNvPr id="5" name="Shape 3"/>
+            <a:ext cx="5003597" cy="2814523"/>
+          </a:xfrm>
+          <a:prstGeom prst="rect">
+            <a:avLst/>
+          </a:prstGeom>
+        </p:spPr>
+      </p:pic>
+      <p:sp>
+        <p:nvSpPr>
+          <p:cNvPr id="4" name="Shape 1"/>
           <p:cNvSpPr/>
           <p:nvPr/>
         </p:nvSpPr>
@@ -3634,7 +3542,7 @@
       </p:sp>
       <p:sp>
         <p:nvSpPr>
-          <p:cNvPr id="6" name="Text 4"/>
+          <p:cNvPr id="5" name="Text 2"/>
           <p:cNvSpPr txBox="1"/>
           <p:nvPr/>
         </p:nvSpPr>
@@ -3670,7 +3578,7 @@
       </p:sp>
       <p:sp>
         <p:nvSpPr>
-          <p:cNvPr id="7" name="Text 5"/>
+          <p:cNvPr id="6" name="Text 3"/>
           <p:cNvSpPr txBox="1"/>
           <p:nvPr/>
         </p:nvSpPr>
@@ -3706,7 +3614,7 @@
       </p:sp>
       <p:sp>
         <p:nvSpPr>
-          <p:cNvPr id="8" name="Text 6"/>
+          <p:cNvPr id="7" name="Text 4"/>
           <p:cNvSpPr txBox="1"/>
           <p:nvPr/>
         </p:nvSpPr>
@@ -3742,7 +3650,7 @@
       </p:sp>
       <p:sp>
         <p:nvSpPr>
-          <p:cNvPr id="9" name="Text 7"/>
+          <p:cNvPr id="8" name="Text 5"/>
           <p:cNvSpPr txBox="1"/>
           <p:nvPr/>
         </p:nvSpPr>
@@ -4589,7 +4497,7 @@
         <p:spPr>
           <a:xfrm>
             <a:off x="1097280" y="1508760"/>
-            <a:ext cx="9997135" cy="4663440"/>
+            <a:ext cx="6217920" cy="4663440"/>
           </a:xfrm>
           <a:prstGeom prst="roundRect">
             <a:avLst>
@@ -4655,7 +4563,7 @@
         <p:spPr>
           <a:xfrm>
             <a:off x="1508760" y="2240280"/>
-            <a:ext cx="9174175" cy="727456"/>
+            <a:ext cx="5394960" cy="603504"/>
           </a:xfrm>
           <a:prstGeom prst="rect">
             <a:avLst/>
@@ -4671,7 +4579,7 @@
               <a:buNone/>
             </a:pPr>
             <a:r>
-              <a:rPr lang="en-US" sz="2200" dirty="0">
+              <a:rPr lang="en-US" sz="1800" dirty="0">
                 <a:solidFill>
                   <a:srgbClr val="1B1B1F"/>
                 </a:solidFill>
@@ -4679,7 +4587,7 @@
               <a:t>Anmelden immer über </a:t>
             </a:r>
             <a:r>
-              <a:rPr lang="en-US" sz="2200" b="1" dirty="0">
+              <a:rPr lang="en-US" sz="1800" b="1" dirty="0">
                 <a:solidFill>
                   <a:srgbClr val="1B1B1F"/>
                 </a:solidFill>
@@ -4687,7 +4595,7 @@
               <a:t>InfoLabs</a:t>
             </a:r>
             <a:r>
-              <a:rPr lang="en-US" sz="2200" dirty="0">
+              <a:rPr lang="en-US" sz="1800" dirty="0">
                 <a:solidFill>
                   <a:srgbClr val="1B1B1F"/>
                 </a:solidFill>
@@ -4695,14 +4603,14 @@
               <a:t>: einmal Kurscode + Name, danach </a:t>
             </a:r>
             <a:r>
-              <a:rPr lang="en-US" sz="2200" b="1" dirty="0">
+              <a:rPr lang="en-US" sz="1800" b="1" dirty="0">
                 <a:solidFill>
                   <a:srgbClr val="1B1B1F"/>
                 </a:solidFill>
               </a:rPr>
               <a:t>Name + persönlicher Code</a:t>
             </a:r>
-            <a:endParaRPr lang="en-US" sz="2200" dirty="0"/>
+            <a:endParaRPr lang="en-US" sz="1800" dirty="0"/>
           </a:p>
         </p:txBody>
       </p:sp>
@@ -4714,8 +4622,8 @@
         </p:nvSpPr>
         <p:spPr>
           <a:xfrm>
-            <a:off x="1508760" y="3095752"/>
-            <a:ext cx="9174175" cy="727456"/>
+            <a:off x="1508760" y="2971800"/>
+            <a:ext cx="5394960" cy="603504"/>
           </a:xfrm>
           <a:prstGeom prst="rect">
             <a:avLst/>
@@ -4731,7 +4639,7 @@
               <a:buNone/>
             </a:pPr>
             <a:r>
-              <a:rPr lang="en-US" sz="2200" dirty="0">
+              <a:rPr lang="en-US" sz="1800" dirty="0">
                 <a:solidFill>
                   <a:srgbClr val="1B1B1F"/>
                 </a:solidFill>
@@ -4739,7 +4647,7 @@
               <a:t>„</a:t>
             </a:r>
             <a:r>
-              <a:rPr lang="en-US" sz="2200" b="1" dirty="0">
+              <a:rPr lang="en-US" sz="1800" b="1" dirty="0">
                 <a:solidFill>
                   <a:srgbClr val="1B1B1F"/>
                 </a:solidFill>
@@ -4747,14 +4655,14 @@
               <a:t>Weiter zu Kryptos</a:t>
             </a:r>
             <a:r>
-              <a:rPr lang="en-US" sz="2200" dirty="0">
+              <a:rPr lang="en-US" sz="1800" dirty="0">
                 <a:solidFill>
                   <a:srgbClr val="1B1B1F"/>
                 </a:solidFill>
               </a:rPr>
               <a:t>“ – kein eigenes Passwort; Code notieren und für dich behalten</a:t>
             </a:r>
-            <a:endParaRPr lang="en-US" sz="2200" dirty="0"/>
+            <a:endParaRPr lang="en-US" sz="1800" dirty="0"/>
           </a:p>
         </p:txBody>
       </p:sp>
@@ -4766,8 +4674,8 @@
         </p:nvSpPr>
         <p:spPr>
           <a:xfrm>
-            <a:off x="1508760" y="3951224"/>
-            <a:ext cx="9174175" cy="727456"/>
+            <a:off x="1508760" y="3703320"/>
+            <a:ext cx="5394960" cy="882396"/>
           </a:xfrm>
           <a:prstGeom prst="rect">
             <a:avLst/>
@@ -4783,7 +4691,7 @@
               <a:buNone/>
             </a:pPr>
             <a:r>
-              <a:rPr lang="en-US" sz="2200" dirty="0">
+              <a:rPr lang="en-US" sz="1800" dirty="0">
                 <a:solidFill>
                   <a:srgbClr val="1B1B1F"/>
                 </a:solidFill>
@@ -4791,7 +4699,7 @@
               <a:t>Tipp − 20 %, Fehlversuch − 25 %, „Lösung zeigen“ 0 – die </a:t>
             </a:r>
             <a:r>
-              <a:rPr lang="en-US" sz="2200" b="1" dirty="0">
+              <a:rPr lang="en-US" sz="1800" b="1" dirty="0">
                 <a:solidFill>
                   <a:srgbClr val="1B1B1F"/>
                 </a:solidFill>
@@ -4799,14 +4707,14 @@
               <a:t>Fallen P1–P10</a:t>
             </a:r>
             <a:r>
-              <a:rPr lang="en-US" sz="2200" dirty="0">
+              <a:rPr lang="en-US" sz="1800" dirty="0">
                 <a:solidFill>
                   <a:srgbClr val="1B1B1F"/>
                 </a:solidFill>
               </a:rPr>
               <a:t> zeigen deine Stolpersteine</a:t>
             </a:r>
-            <a:endParaRPr lang="en-US" sz="2200" dirty="0"/>
+            <a:endParaRPr lang="en-US" sz="1800" dirty="0"/>
           </a:p>
         </p:txBody>
       </p:sp>
@@ -4818,8 +4726,8 @@
         </p:nvSpPr>
         <p:spPr>
           <a:xfrm>
-            <a:off x="1508760" y="4806696"/>
-            <a:ext cx="9174175" cy="727456"/>
+            <a:off x="1508760" y="4713732"/>
+            <a:ext cx="5394960" cy="603504"/>
           </a:xfrm>
           <a:prstGeom prst="rect">
             <a:avLst/>
@@ -4835,7 +4743,7 @@
               <a:buNone/>
             </a:pPr>
             <a:r>
-              <a:rPr lang="en-US" sz="2200" dirty="0">
+              <a:rPr lang="en-US" sz="1800" dirty="0">
                 <a:solidFill>
                   <a:srgbClr val="1B1B1F"/>
                 </a:solidFill>
@@ -4843,7 +4751,7 @@
               <a:t>Jede Epoche: Level, Trainingsplatz, </a:t>
             </a:r>
             <a:r>
-              <a:rPr lang="en-US" sz="2200" b="1" dirty="0">
+              <a:rPr lang="en-US" sz="1800" b="1" dirty="0">
                 <a:solidFill>
                   <a:srgbClr val="1B1B1F"/>
                 </a:solidFill>
@@ -4851,14 +4759,14 @@
               <a:t>Boss</a:t>
             </a:r>
             <a:r>
-              <a:rPr lang="en-US" sz="2200" dirty="0">
+              <a:rPr lang="en-US" sz="1800" dirty="0">
                 <a:solidFill>
                   <a:srgbClr val="1B1B1F"/>
                 </a:solidFill>
               </a:rPr>
               <a:t> – dazu Kryptolabor, Funkraum und Gastmodus</a:t>
             </a:r>
-            <a:endParaRPr lang="en-US" sz="2200" dirty="0"/>
+            <a:endParaRPr lang="en-US" sz="1800" dirty="0"/>
           </a:p>
         </p:txBody>
       </p:sp>
@@ -6308,79 +6216,33 @@
           </a:p>
         </p:txBody>
       </p:sp>
-      <p:sp>
-        <p:nvSpPr>
-          <p:cNvPr id="3" name="Bildplatzhalter"/>
-          <p:cNvSpPr/>
+      <p:pic>
+        <p:nvPicPr>
+          <p:cNvPr id="3" name="Image 0" descr="Screenshot Portal labs.frankjuchim.de, Reiter „Kurs beitreten“: Felder „Kurscode“ und „Name“; daneben Reiter „Anmelden“ (Name + persönlicher Code). Demo-Kurs, alle Codes unkenntlich.">    </p:cNvPr>
+          <p:cNvPicPr>
+            <a:picLocks noChangeAspect="1"/>
+          </p:cNvPicPr>
           <p:nvPr/>
-        </p:nvSpPr>
+        </p:nvPicPr>
+        <p:blipFill>
+          <a:blip r:embed="rId1"/>
+          <a:stretch>
+            <a:fillRect/>
+          </a:stretch>
+        </p:blipFill>
         <p:spPr>
           <a:xfrm>
             <a:off x="548640" y="1325880"/>
-            <a:ext cx="4586630" cy="2926080"/>
-          </a:xfrm>
-          <a:prstGeom prst="rect">
-            <a:avLst/>
-          </a:prstGeom>
-          <a:solidFill>
-            <a:srgbClr val="FFFFFF"/>
-          </a:solidFill>
-          <a:ln w="15875">
-            <a:solidFill>
-              <a:srgbClr val="4A4A55"/>
-            </a:solidFill>
-            <a:prstDash val="dash"/>
-          </a:ln>
-        </p:spPr>
-      </p:sp>
-      <p:sp>
-        <p:nvSpPr>
-          <p:cNvPr id="4" name="Text 2"/>
-          <p:cNvSpPr txBox="1"/>
-          <p:nvPr/>
-        </p:nvSpPr>
-        <p:spPr>
-          <a:xfrm>
-            <a:off x="822960" y="1600200"/>
-            <a:ext cx="4037990" cy="2377440"/>
-          </a:xfrm>
-          <a:prstGeom prst="rect">
-            <a:avLst/>
-          </a:prstGeom>
-          <a:noFill/>
-          <a:ln/>
-        </p:spPr>
-        <p:txBody>
-          <a:bodyPr wrap="square" lIns="0" tIns="0" rIns="0" bIns="0" rtlCol="0" anchor="ctr"/>
-          <a:lstStyle/>
-          <a:p>
-            <a:pPr algn="ctr" indent="0" marL="0">
-              <a:buNone/>
-            </a:pPr>
-            <a:r>
-              <a:rPr lang="en-US" sz="1400" b="1" spc="200" kern="0" dirty="0">
-                <a:solidFill>
-                  <a:srgbClr val="4A4A55"/>
-                </a:solidFill>
-              </a:rPr>
-              <a:t>BILD EINFÜGEN
-</a:t>
-            </a:r>
-            <a:r>
-              <a:rPr lang="en-US" sz="1400" dirty="0">
-                <a:solidFill>
-                  <a:srgbClr val="4A4A55"/>
-                </a:solidFill>
-              </a:rPr>
-              <a:t>Screenshot Portal labs.frankjuchim.de, Reiter „Kurs beitreten“: Felder „Kurscode“ und „Name“; daneben Reiter „Anmelden“ (Name + persönlicher Code). Demo-Kurs, alle Codes unkenntlich.</a:t>
-            </a:r>
-            <a:endParaRPr lang="en-US" sz="1400" dirty="0"/>
-          </a:p>
-        </p:txBody>
-      </p:sp>
-      <p:sp>
-        <p:nvSpPr>
-          <p:cNvPr id="5" name="Shape 3"/>
+            <a:ext cx="4586630" cy="2866644"/>
+          </a:xfrm>
+          <a:prstGeom prst="rect">
+            <a:avLst/>
+          </a:prstGeom>
+        </p:spPr>
+      </p:pic>
+      <p:sp>
+        <p:nvSpPr>
+          <p:cNvPr id="4" name="Shape 1"/>
           <p:cNvSpPr/>
           <p:nvPr/>
         </p:nvSpPr>
@@ -6407,7 +6269,7 @@
       </p:sp>
       <p:sp>
         <p:nvSpPr>
-          <p:cNvPr id="6" name="Text 4"/>
+          <p:cNvPr id="5" name="Text 2"/>
           <p:cNvSpPr txBox="1"/>
           <p:nvPr/>
         </p:nvSpPr>
@@ -6432,7 +6294,7 @@
             <a:r>
               <a:rPr lang="en-US" sz="1300" b="1" spc="200" kern="0" dirty="0">
                 <a:solidFill>
-                  <a:srgbClr val="8A5F1A"/>
+                  <a:srgbClr val="14213D"/>
                 </a:solidFill>
               </a:rPr>
               <a:t>SO GEHT’S</a:t>
@@ -6443,7 +6305,7 @@
       </p:sp>
       <p:sp>
         <p:nvSpPr>
-          <p:cNvPr id="7" name="Text 5"/>
+          <p:cNvPr id="6" name="Text 3"/>
           <p:cNvSpPr txBox="1"/>
           <p:nvPr/>
         </p:nvSpPr>
@@ -6487,7 +6349,7 @@
       </p:sp>
       <p:sp>
         <p:nvSpPr>
-          <p:cNvPr id="8" name="Text 6"/>
+          <p:cNvPr id="7" name="Text 4"/>
           <p:cNvSpPr txBox="1"/>
           <p:nvPr/>
         </p:nvSpPr>
@@ -6547,7 +6409,7 @@
       </p:sp>
       <p:sp>
         <p:nvSpPr>
-          <p:cNvPr id="9" name="Text 7"/>
+          <p:cNvPr id="8" name="Text 5"/>
           <p:cNvSpPr txBox="1"/>
           <p:nvPr/>
         </p:nvSpPr>
@@ -6591,7 +6453,7 @@
       </p:sp>
       <p:sp>
         <p:nvSpPr>
-          <p:cNvPr id="10" name="Text 8"/>
+          <p:cNvPr id="9" name="Text 6"/>
           <p:cNvSpPr txBox="1"/>
           <p:nvPr/>
         </p:nvSpPr>
@@ -6744,79 +6606,33 @@
           </a:p>
         </p:txBody>
       </p:sp>
-      <p:sp>
-        <p:nvSpPr>
-          <p:cNvPr id="3" name="Bildplatzhalter"/>
-          <p:cNvSpPr/>
+      <p:pic>
+        <p:nvPicPr>
+          <p:cNvPr id="3" name="Image 0" descr="Screenshot Portal „Meine Plattformen“: Karte „Kryptos – Die Zeitreise der Geheimschriften“ (Messing auf Tintenblau) mit Knopf „Weiter zu Kryptos“.">    </p:cNvPr>
+          <p:cNvPicPr>
+            <a:picLocks noChangeAspect="1"/>
+          </p:cNvPicPr>
           <p:nvPr/>
-        </p:nvSpPr>
+        </p:nvPicPr>
+        <p:blipFill>
+          <a:blip r:embed="rId1"/>
+          <a:stretch>
+            <a:fillRect/>
+          </a:stretch>
+        </p:blipFill>
         <p:spPr>
           <a:xfrm>
             <a:off x="548640" y="1325880"/>
-            <a:ext cx="4586630" cy="2926080"/>
-          </a:xfrm>
-          <a:prstGeom prst="rect">
-            <a:avLst/>
-          </a:prstGeom>
-          <a:solidFill>
-            <a:srgbClr val="FFFFFF"/>
-          </a:solidFill>
-          <a:ln w="15875">
-            <a:solidFill>
-              <a:srgbClr val="4A4A55"/>
-            </a:solidFill>
-            <a:prstDash val="dash"/>
-          </a:ln>
-        </p:spPr>
-      </p:sp>
-      <p:sp>
-        <p:nvSpPr>
-          <p:cNvPr id="4" name="Text 2"/>
-          <p:cNvSpPr txBox="1"/>
-          <p:nvPr/>
-        </p:nvSpPr>
-        <p:spPr>
-          <a:xfrm>
-            <a:off x="822960" y="1600200"/>
-            <a:ext cx="4037990" cy="2377440"/>
-          </a:xfrm>
-          <a:prstGeom prst="rect">
-            <a:avLst/>
-          </a:prstGeom>
-          <a:noFill/>
-          <a:ln/>
-        </p:spPr>
-        <p:txBody>
-          <a:bodyPr wrap="square" lIns="0" tIns="0" rIns="0" bIns="0" rtlCol="0" anchor="ctr"/>
-          <a:lstStyle/>
-          <a:p>
-            <a:pPr algn="ctr" indent="0" marL="0">
-              <a:buNone/>
-            </a:pPr>
-            <a:r>
-              <a:rPr lang="en-US" sz="1400" b="1" spc="200" kern="0" dirty="0">
-                <a:solidFill>
-                  <a:srgbClr val="4A4A55"/>
-                </a:solidFill>
-              </a:rPr>
-              <a:t>BILD EINFÜGEN
-</a:t>
-            </a:r>
-            <a:r>
-              <a:rPr lang="en-US" sz="1400" dirty="0">
-                <a:solidFill>
-                  <a:srgbClr val="4A4A55"/>
-                </a:solidFill>
-              </a:rPr>
-              <a:t>Screenshot Portal „Meine Plattformen“: Karte „Kryptos – Die Zeitreise der Geheimschriften“ (Messing auf Tintenblau) mit Knopf „Weiter zu Kryptos“.</a:t>
-            </a:r>
-            <a:endParaRPr lang="en-US" sz="1400" dirty="0"/>
-          </a:p>
-        </p:txBody>
-      </p:sp>
-      <p:sp>
-        <p:nvSpPr>
-          <p:cNvPr id="5" name="Shape 3"/>
+            <a:ext cx="4586630" cy="2866644"/>
+          </a:xfrm>
+          <a:prstGeom prst="rect">
+            <a:avLst/>
+          </a:prstGeom>
+        </p:spPr>
+      </p:pic>
+      <p:sp>
+        <p:nvSpPr>
+          <p:cNvPr id="4" name="Shape 1"/>
           <p:cNvSpPr/>
           <p:nvPr/>
         </p:nvSpPr>
@@ -6843,7 +6659,7 @@
       </p:sp>
       <p:sp>
         <p:nvSpPr>
-          <p:cNvPr id="6" name="Text 4"/>
+          <p:cNvPr id="5" name="Text 2"/>
           <p:cNvSpPr txBox="1"/>
           <p:nvPr/>
         </p:nvSpPr>
@@ -6879,7 +6695,7 @@
       </p:sp>
       <p:sp>
         <p:nvSpPr>
-          <p:cNvPr id="7" name="Text 5"/>
+          <p:cNvPr id="6" name="Text 3"/>
           <p:cNvSpPr txBox="1"/>
           <p:nvPr/>
         </p:nvSpPr>
@@ -6931,7 +6747,7 @@
       </p:sp>
       <p:sp>
         <p:nvSpPr>
-          <p:cNvPr id="8" name="Text 6"/>
+          <p:cNvPr id="7" name="Text 4"/>
           <p:cNvSpPr txBox="1"/>
           <p:nvPr/>
         </p:nvSpPr>
@@ -6967,7 +6783,7 @@
       </p:sp>
       <p:sp>
         <p:nvSpPr>
-          <p:cNvPr id="9" name="Text 7"/>
+          <p:cNvPr id="8" name="Text 5"/>
           <p:cNvSpPr txBox="1"/>
           <p:nvPr/>
         </p:nvSpPr>
@@ -7003,7 +6819,7 @@
       </p:sp>
       <p:sp>
         <p:nvSpPr>
-          <p:cNvPr id="10" name="Text 8"/>
+          <p:cNvPr id="9" name="Text 6"/>
           <p:cNvSpPr txBox="1"/>
           <p:nvPr/>
         </p:nvSpPr>
@@ -7156,79 +6972,33 @@
           </a:p>
         </p:txBody>
       </p:sp>
-      <p:sp>
-        <p:nvSpPr>
-          <p:cNvPr id="3" name="Bildplatzhalter"/>
-          <p:cNvSpPr/>
+      <p:pic>
+        <p:nvPicPr>
+          <p:cNvPr id="3" name="Image 0" descr="Screenshot Kryptos-Startseite: Zeitleiste von 500 v. Chr. bis heute auf Nachtblau, sieben Epochen-Tore (Antike, Bagdad, Renaissance, Maschinenzeitalter, Stanford 1976, Das Netz, Zeitmaschine) mit Fortschrittsring und Artefakt-Symbol; gesperrte Tore in Geheimtext-Optik mit „noch verschlüsselt“; Kopfzeile mit „⌂ Portal“, Labor, Profil.">    </p:cNvPr>
+          <p:cNvPicPr>
+            <a:picLocks noChangeAspect="1"/>
+          </p:cNvPicPr>
           <p:nvPr/>
-        </p:nvSpPr>
+        </p:nvPicPr>
+        <p:blipFill>
+          <a:blip r:embed="rId1"/>
+          <a:stretch>
+            <a:fillRect/>
+          </a:stretch>
+        </p:blipFill>
         <p:spPr>
           <a:xfrm>
             <a:off x="548640" y="1325880"/>
-            <a:ext cx="5003597" cy="2926080"/>
-          </a:xfrm>
-          <a:prstGeom prst="rect">
-            <a:avLst/>
-          </a:prstGeom>
-          <a:solidFill>
-            <a:srgbClr val="FFFFFF"/>
-          </a:solidFill>
-          <a:ln w="15875">
-            <a:solidFill>
-              <a:srgbClr val="4A4A55"/>
-            </a:solidFill>
-            <a:prstDash val="dash"/>
-          </a:ln>
-        </p:spPr>
-      </p:sp>
-      <p:sp>
-        <p:nvSpPr>
-          <p:cNvPr id="4" name="Text 2"/>
-          <p:cNvSpPr txBox="1"/>
-          <p:nvPr/>
-        </p:nvSpPr>
-        <p:spPr>
-          <a:xfrm>
-            <a:off x="822960" y="1600200"/>
-            <a:ext cx="4454957" cy="2377440"/>
-          </a:xfrm>
-          <a:prstGeom prst="rect">
-            <a:avLst/>
-          </a:prstGeom>
-          <a:noFill/>
-          <a:ln/>
-        </p:spPr>
-        <p:txBody>
-          <a:bodyPr wrap="square" lIns="0" tIns="0" rIns="0" bIns="0" rtlCol="0" anchor="ctr"/>
-          <a:lstStyle/>
-          <a:p>
-            <a:pPr algn="ctr" indent="0" marL="0">
-              <a:buNone/>
-            </a:pPr>
-            <a:r>
-              <a:rPr lang="en-US" sz="1400" b="1" spc="200" kern="0" dirty="0">
-                <a:solidFill>
-                  <a:srgbClr val="4A4A55"/>
-                </a:solidFill>
-              </a:rPr>
-              <a:t>BILD EINFÜGEN
-</a:t>
-            </a:r>
-            <a:r>
-              <a:rPr lang="en-US" sz="1400" dirty="0">
-                <a:solidFill>
-                  <a:srgbClr val="4A4A55"/>
-                </a:solidFill>
-              </a:rPr>
-              <a:t>Screenshot Kryptos-Startseite: Zeitleiste von 500 v. Chr. bis heute auf Nachtblau, sieben Epochen-Tore (Antike, Bagdad, Renaissance, Maschinenzeitalter, Stanford 1976, Das Netz, Zeitmaschine) mit Fortschrittsring und Artefakt-Symbol; gesperrte Tore in Geheimtext-Optik mit „noch verschlüsselt“; Kopfzeile mit „⌂ Portal“, Labor, Profil.</a:t>
-            </a:r>
-            <a:endParaRPr lang="en-US" sz="1400" dirty="0"/>
-          </a:p>
-        </p:txBody>
-      </p:sp>
-      <p:sp>
-        <p:nvSpPr>
-          <p:cNvPr id="5" name="Shape 3"/>
+            <a:ext cx="5003597" cy="2814523"/>
+          </a:xfrm>
+          <a:prstGeom prst="rect">
+            <a:avLst/>
+          </a:prstGeom>
+        </p:spPr>
+      </p:pic>
+      <p:sp>
+        <p:nvSpPr>
+          <p:cNvPr id="4" name="Shape 1"/>
           <p:cNvSpPr/>
           <p:nvPr/>
         </p:nvSpPr>
@@ -7255,7 +7025,7 @@
       </p:sp>
       <p:sp>
         <p:nvSpPr>
-          <p:cNvPr id="6" name="Text 4"/>
+          <p:cNvPr id="5" name="Text 2"/>
           <p:cNvSpPr txBox="1"/>
           <p:nvPr/>
         </p:nvSpPr>
@@ -7291,7 +7061,7 @@
       </p:sp>
       <p:sp>
         <p:nvSpPr>
-          <p:cNvPr id="7" name="Text 5"/>
+          <p:cNvPr id="6" name="Text 3"/>
           <p:cNvSpPr txBox="1"/>
           <p:nvPr/>
         </p:nvSpPr>
@@ -7327,7 +7097,7 @@
       </p:sp>
       <p:sp>
         <p:nvSpPr>
-          <p:cNvPr id="8" name="Text 6"/>
+          <p:cNvPr id="7" name="Text 4"/>
           <p:cNvSpPr txBox="1"/>
           <p:nvPr/>
         </p:nvSpPr>
@@ -7363,7 +7133,7 @@
       </p:sp>
       <p:sp>
         <p:nvSpPr>
-          <p:cNvPr id="9" name="Text 7"/>
+          <p:cNvPr id="8" name="Text 5"/>
           <p:cNvSpPr txBox="1"/>
           <p:nvPr/>
         </p:nvSpPr>
@@ -7399,7 +7169,7 @@
       </p:sp>
       <p:sp>
         <p:nvSpPr>
-          <p:cNvPr id="10" name="Text 8"/>
+          <p:cNvPr id="9" name="Text 6"/>
           <p:cNvSpPr txBox="1"/>
           <p:nvPr/>
         </p:nvSpPr>
@@ -7544,79 +7314,33 @@
           </a:p>
         </p:txBody>
       </p:sp>
-      <p:sp>
-        <p:nvSpPr>
-          <p:cNvPr id="3" name="Bildplatzhalter"/>
-          <p:cNvSpPr/>
+      <p:pic>
+        <p:nvPicPr>
+          <p:cNvPr id="3" name="Image 0" descr="Screenshot Level-Seite „Caesars Botschaft“ (Akte W0·2): Kasten „Archivwissen“, Rollen-Chip 🛡/🔍, Aufgabenliste mit ★ bis ★★★ und Fortschritt, eingebettete Chiffrierscheibe, Karte „Akte als PDF“ mit QR-Code.">    </p:cNvPr>
+          <p:cNvPicPr>
+            <a:picLocks noChangeAspect="1"/>
+          </p:cNvPicPr>
           <p:nvPr/>
-        </p:nvSpPr>
+        </p:nvPicPr>
+        <p:blipFill>
+          <a:blip r:embed="rId1"/>
+          <a:stretch>
+            <a:fillRect/>
+          </a:stretch>
+        </p:blipFill>
         <p:spPr>
           <a:xfrm>
             <a:off x="548640" y="1325880"/>
-            <a:ext cx="5003597" cy="2926080"/>
-          </a:xfrm>
-          <a:prstGeom prst="rect">
-            <a:avLst/>
-          </a:prstGeom>
-          <a:solidFill>
-            <a:srgbClr val="FFFFFF"/>
-          </a:solidFill>
-          <a:ln w="15875">
-            <a:solidFill>
-              <a:srgbClr val="4A4A55"/>
-            </a:solidFill>
-            <a:prstDash val="dash"/>
-          </a:ln>
-        </p:spPr>
-      </p:sp>
-      <p:sp>
-        <p:nvSpPr>
-          <p:cNvPr id="4" name="Text 2"/>
-          <p:cNvSpPr txBox="1"/>
-          <p:nvPr/>
-        </p:nvSpPr>
-        <p:spPr>
-          <a:xfrm>
-            <a:off x="822960" y="1600200"/>
-            <a:ext cx="4454957" cy="2377440"/>
-          </a:xfrm>
-          <a:prstGeom prst="rect">
-            <a:avLst/>
-          </a:prstGeom>
-          <a:noFill/>
-          <a:ln/>
-        </p:spPr>
-        <p:txBody>
-          <a:bodyPr wrap="square" lIns="0" tIns="0" rIns="0" bIns="0" rtlCol="0" anchor="ctr"/>
-          <a:lstStyle/>
-          <a:p>
-            <a:pPr algn="ctr" indent="0" marL="0">
-              <a:buNone/>
-            </a:pPr>
-            <a:r>
-              <a:rPr lang="en-US" sz="1400" b="1" spc="200" kern="0" dirty="0">
-                <a:solidFill>
-                  <a:srgbClr val="4A4A55"/>
-                </a:solidFill>
-              </a:rPr>
-              <a:t>BILD EINFÜGEN
-</a:t>
-            </a:r>
-            <a:r>
-              <a:rPr lang="en-US" sz="1400" dirty="0">
-                <a:solidFill>
-                  <a:srgbClr val="4A4A55"/>
-                </a:solidFill>
-              </a:rPr>
-              <a:t>Screenshot Level-Seite „Caesars Botschaft“ (Akte W0·2): Kasten „Archivwissen“, Rollen-Chip 🛡/🔍, Aufgabenliste mit ★ bis ★★★ und Fortschritt, eingebettete Chiffrierscheibe, Karte „Akte als PDF“ mit QR-Code.</a:t>
-            </a:r>
-            <a:endParaRPr lang="en-US" sz="1400" dirty="0"/>
-          </a:p>
-        </p:txBody>
-      </p:sp>
-      <p:sp>
-        <p:nvSpPr>
-          <p:cNvPr id="5" name="Shape 3"/>
+            <a:ext cx="5003597" cy="2814523"/>
+          </a:xfrm>
+          <a:prstGeom prst="rect">
+            <a:avLst/>
+          </a:prstGeom>
+        </p:spPr>
+      </p:pic>
+      <p:sp>
+        <p:nvSpPr>
+          <p:cNvPr id="4" name="Shape 1"/>
           <p:cNvSpPr/>
           <p:nvPr/>
         </p:nvSpPr>
@@ -7643,7 +7367,7 @@
       </p:sp>
       <p:sp>
         <p:nvSpPr>
-          <p:cNvPr id="6" name="Text 4"/>
+          <p:cNvPr id="5" name="Text 2"/>
           <p:cNvSpPr txBox="1"/>
           <p:nvPr/>
         </p:nvSpPr>
@@ -7668,7 +7392,7 @@
             <a:r>
               <a:rPr lang="en-US" sz="1300" b="1" spc="200" kern="0" dirty="0">
                 <a:solidFill>
-                  <a:srgbClr val="8A5F1A"/>
+                  <a:srgbClr val="14213D"/>
                 </a:solidFill>
               </a:rPr>
               <a:t>IM LEVEL</a:t>
@@ -7679,7 +7403,7 @@
       </p:sp>
       <p:sp>
         <p:nvSpPr>
-          <p:cNvPr id="7" name="Text 5"/>
+          <p:cNvPr id="6" name="Text 3"/>
           <p:cNvSpPr txBox="1"/>
           <p:nvPr/>
         </p:nvSpPr>
@@ -7715,7 +7439,7 @@
       </p:sp>
       <p:sp>
         <p:nvSpPr>
-          <p:cNvPr id="8" name="Text 6"/>
+          <p:cNvPr id="7" name="Text 4"/>
           <p:cNvSpPr txBox="1"/>
           <p:nvPr/>
         </p:nvSpPr>
@@ -7751,7 +7475,7 @@
       </p:sp>
       <p:sp>
         <p:nvSpPr>
-          <p:cNvPr id="9" name="Text 7"/>
+          <p:cNvPr id="8" name="Text 5"/>
           <p:cNvSpPr txBox="1"/>
           <p:nvPr/>
         </p:nvSpPr>
@@ -7787,7 +7511,7 @@
       </p:sp>
       <p:sp>
         <p:nvSpPr>
-          <p:cNvPr id="10" name="Text 8"/>
+          <p:cNvPr id="9" name="Text 6"/>
           <p:cNvSpPr txBox="1"/>
           <p:nvPr/>
         </p:nvSpPr>
@@ -7976,7 +7700,7 @@
                         <a:buNone/>
                       </a:pPr>
                       <a:r>
-                        <a:rPr lang="en-US" sz="1600" b="1" dirty="0">
+                        <a:rPr lang="en-US" sz="1800" b="1" dirty="0">
                           <a:solidFill>
                             <a:srgbClr val="1B1B1F"/>
                           </a:solidFill>
@@ -7986,7 +7710,7 @@
                         </a:rPr>
                         <a:t>Aufgabe</a:t>
                       </a:r>
-                      <a:endParaRPr lang="en-US" sz="1600" dirty="0">
+                      <a:endParaRPr lang="en-US" sz="1800" dirty="0">
                         <a:latin typeface="Calibri" charset="0"/>
                         <a:ea typeface="Calibri" charset="0"/>
                         <a:cs typeface="Calibri" charset="0"/>
@@ -8044,7 +7768,7 @@
                         <a:buNone/>
                       </a:pPr>
                       <a:r>
-                        <a:rPr lang="en-US" sz="1600" b="1" dirty="0">
+                        <a:rPr lang="en-US" sz="1800" b="1" dirty="0">
                           <a:solidFill>
                             <a:srgbClr val="1B1B1F"/>
                           </a:solidFill>
@@ -8054,7 +7778,7 @@
                         </a:rPr>
                         <a:t>Punkte</a:t>
                       </a:r>
-                      <a:endParaRPr lang="en-US" sz="1600" dirty="0">
+                      <a:endParaRPr lang="en-US" sz="1800" dirty="0">
                         <a:latin typeface="Calibri" charset="0"/>
                         <a:ea typeface="Calibri" charset="0"/>
                         <a:cs typeface="Calibri" charset="0"/>
@@ -8114,7 +7838,7 @@
                         <a:buNone/>
                       </a:pPr>
                       <a:r>
-                        <a:rPr lang="en-US" sz="1600" dirty="0">
+                        <a:rPr lang="en-US" sz="1800" dirty="0">
                           <a:solidFill>
                             <a:srgbClr val="1B1B1F"/>
                           </a:solidFill>
@@ -8124,7 +7848,7 @@
                         </a:rPr>
                         <a:t>★ 10 P., sofort richtig</a:t>
                       </a:r>
-                      <a:endParaRPr lang="en-US" sz="1600" dirty="0">
+                      <a:endParaRPr lang="en-US" sz="1800" dirty="0">
                         <a:latin typeface="Calibri" charset="0"/>
                         <a:ea typeface="Calibri" charset="0"/>
                         <a:cs typeface="Calibri" charset="0"/>
@@ -8182,7 +7906,7 @@
                         <a:buNone/>
                       </a:pPr>
                       <a:r>
-                        <a:rPr lang="en-US" sz="1600" dirty="0">
+                        <a:rPr lang="en-US" sz="1800" dirty="0">
                           <a:solidFill>
                             <a:srgbClr val="1B1B1F"/>
                           </a:solidFill>
@@ -8192,7 +7916,7 @@
                         </a:rPr>
                         <a:t>10</a:t>
                       </a:r>
-                      <a:endParaRPr lang="en-US" sz="1600" dirty="0">
+                      <a:endParaRPr lang="en-US" sz="1800" dirty="0">
                         <a:latin typeface="Calibri" charset="0"/>
                         <a:ea typeface="Calibri" charset="0"/>
                         <a:cs typeface="Calibri" charset="0"/>
@@ -8252,7 +7976,7 @@
                         <a:buNone/>
                       </a:pPr>
                       <a:r>
-                        <a:rPr lang="en-US" sz="1600" dirty="0">
+                        <a:rPr lang="en-US" sz="1800" dirty="0">
                           <a:solidFill>
                             <a:srgbClr val="1B1B1F"/>
                           </a:solidFill>
@@ -8262,7 +7986,7 @@
                         </a:rPr>
                         <a:t>★★ 20 P., mit 1 Tipp</a:t>
                       </a:r>
-                      <a:endParaRPr lang="en-US" sz="1600" dirty="0">
+                      <a:endParaRPr lang="en-US" sz="1800" dirty="0">
                         <a:latin typeface="Calibri" charset="0"/>
                         <a:ea typeface="Calibri" charset="0"/>
                         <a:cs typeface="Calibri" charset="0"/>
@@ -8320,7 +8044,7 @@
                         <a:buNone/>
                       </a:pPr>
                       <a:r>
-                        <a:rPr lang="en-US" sz="1600" dirty="0">
+                        <a:rPr lang="en-US" sz="1800" dirty="0">
                           <a:solidFill>
                             <a:srgbClr val="1B1B1F"/>
                           </a:solidFill>
@@ -8330,7 +8054,7 @@
                         </a:rPr>
                         <a:t>16</a:t>
                       </a:r>
-                      <a:endParaRPr lang="en-US" sz="1600" dirty="0">
+                      <a:endParaRPr lang="en-US" sz="1800" dirty="0">
                         <a:latin typeface="Calibri" charset="0"/>
                         <a:ea typeface="Calibri" charset="0"/>
                         <a:cs typeface="Calibri" charset="0"/>
@@ -8390,7 +8114,7 @@
                         <a:buNone/>
                       </a:pPr>
                       <a:r>
-                        <a:rPr lang="en-US" sz="1600" dirty="0">
+                        <a:rPr lang="en-US" sz="1800" dirty="0">
                           <a:solidFill>
                             <a:srgbClr val="1B1B1F"/>
                           </a:solidFill>
@@ -8400,7 +8124,7 @@
                         </a:rPr>
                         <a:t>★★ 20 P., 1 Tipp + 1 Fehlversuch</a:t>
                       </a:r>
-                      <a:endParaRPr lang="en-US" sz="1600" dirty="0">
+                      <a:endParaRPr lang="en-US" sz="1800" dirty="0">
                         <a:latin typeface="Calibri" charset="0"/>
                         <a:ea typeface="Calibri" charset="0"/>
                         <a:cs typeface="Calibri" charset="0"/>
@@ -8458,7 +8182,7 @@
                         <a:buNone/>
                       </a:pPr>
                       <a:r>
-                        <a:rPr lang="en-US" sz="1600" dirty="0">
+                        <a:rPr lang="en-US" sz="1800" dirty="0">
                           <a:solidFill>
                             <a:srgbClr val="1B1B1F"/>
                           </a:solidFill>
@@ -8468,7 +8192,7 @@
                         </a:rPr>
                         <a:t>11</a:t>
                       </a:r>
-                      <a:endParaRPr lang="en-US" sz="1600" dirty="0">
+                      <a:endParaRPr lang="en-US" sz="1800" dirty="0">
                         <a:latin typeface="Calibri" charset="0"/>
                         <a:ea typeface="Calibri" charset="0"/>
                         <a:cs typeface="Calibri" charset="0"/>
@@ -8528,7 +8252,7 @@
                         <a:buNone/>
                       </a:pPr>
                       <a:r>
-                        <a:rPr lang="en-US" sz="1600" dirty="0">
+                        <a:rPr lang="en-US" sz="1800" dirty="0">
                           <a:solidFill>
                             <a:srgbClr val="1B1B1F"/>
                           </a:solidFill>
@@ -8538,7 +8262,7 @@
                         </a:rPr>
                         <a:t>★★★ 30 P., 2 Fehlversuche</a:t>
                       </a:r>
-                      <a:endParaRPr lang="en-US" sz="1600" dirty="0">
+                      <a:endParaRPr lang="en-US" sz="1800" dirty="0">
                         <a:latin typeface="Calibri" charset="0"/>
                         <a:ea typeface="Calibri" charset="0"/>
                         <a:cs typeface="Calibri" charset="0"/>
@@ -8596,7 +8320,7 @@
                         <a:buNone/>
                       </a:pPr>
                       <a:r>
-                        <a:rPr lang="en-US" sz="1600" dirty="0">
+                        <a:rPr lang="en-US" sz="1800" dirty="0">
                           <a:solidFill>
                             <a:srgbClr val="1B1B1F"/>
                           </a:solidFill>
@@ -8606,7 +8330,7 @@
                         </a:rPr>
                         <a:t>15</a:t>
                       </a:r>
-                      <a:endParaRPr lang="en-US" sz="1600" dirty="0">
+                      <a:endParaRPr lang="en-US" sz="1800" dirty="0">
                         <a:latin typeface="Calibri" charset="0"/>
                         <a:ea typeface="Calibri" charset="0"/>
                         <a:cs typeface="Calibri" charset="0"/>
@@ -8666,7 +8390,7 @@
                         <a:buNone/>
                       </a:pPr>
                       <a:r>
-                        <a:rPr lang="en-US" sz="1600" dirty="0">
+                        <a:rPr lang="en-US" sz="1800" dirty="0">
                           <a:solidFill>
                             <a:srgbClr val="1B1B1F"/>
                           </a:solidFill>
@@ -8676,7 +8400,7 @@
                         </a:rPr>
                         <a:t>★★ 20 P., 4 Fehlversuche</a:t>
                       </a:r>
-                      <a:endParaRPr lang="en-US" sz="1600" dirty="0">
+                      <a:endParaRPr lang="en-US" sz="1800" dirty="0">
                         <a:latin typeface="Calibri" charset="0"/>
                         <a:ea typeface="Calibri" charset="0"/>
                         <a:cs typeface="Calibri" charset="0"/>
@@ -8734,7 +8458,7 @@
                         <a:buNone/>
                       </a:pPr>
                       <a:r>
-                        <a:rPr lang="en-US" sz="1600" dirty="0">
+                        <a:rPr lang="en-US" sz="1800" dirty="0">
                           <a:solidFill>
                             <a:srgbClr val="1B1B1F"/>
                           </a:solidFill>
@@ -8744,7 +8468,7 @@
                         </a:rPr>
                         <a:t>5</a:t>
                       </a:r>
-                      <a:endParaRPr lang="en-US" sz="1600" dirty="0">
+                      <a:endParaRPr lang="en-US" sz="1800" dirty="0">
                         <a:latin typeface="Calibri" charset="0"/>
                         <a:ea typeface="Calibri" charset="0"/>
                         <a:cs typeface="Calibri" charset="0"/>
@@ -8804,7 +8528,7 @@
                         <a:buNone/>
                       </a:pPr>
                       <a:r>
-                        <a:rPr lang="en-US" sz="1600" dirty="0">
+                        <a:rPr lang="en-US" sz="1800" dirty="0">
                           <a:solidFill>
                             <a:srgbClr val="1B1B1F"/>
                           </a:solidFill>
@@ -8814,7 +8538,7 @@
                         </a:rPr>
                         <a:t>„Lösung zeigen“</a:t>
                       </a:r>
-                      <a:endParaRPr lang="en-US" sz="1600" dirty="0">
+                      <a:endParaRPr lang="en-US" sz="1800" dirty="0">
                         <a:latin typeface="Calibri" charset="0"/>
                         <a:ea typeface="Calibri" charset="0"/>
                         <a:cs typeface="Calibri" charset="0"/>
@@ -8872,7 +8596,7 @@
                         <a:buNone/>
                       </a:pPr>
                       <a:r>
-                        <a:rPr lang="en-US" sz="1600" dirty="0">
+                        <a:rPr lang="en-US" sz="1800" dirty="0">
                           <a:solidFill>
                             <a:srgbClr val="1B1B1F"/>
                           </a:solidFill>
@@ -8882,7 +8606,7 @@
                         </a:rPr>
                         <a:t>0</a:t>
                       </a:r>
-                      <a:endParaRPr lang="en-US" sz="1600" dirty="0">
+                      <a:endParaRPr lang="en-US" sz="1800" dirty="0">
                         <a:latin typeface="Calibri" charset="0"/>
                         <a:ea typeface="Calibri" charset="0"/>
                         <a:cs typeface="Calibri" charset="0"/>
@@ -11268,79 +10992,33 @@
           </a:p>
         </p:txBody>
       </p:sp>
-      <p:sp>
-        <p:nvSpPr>
-          <p:cNvPr id="4" name="Bildplatzhalter"/>
-          <p:cNvSpPr/>
+      <p:pic>
+        <p:nvPicPr>
+          <p:cNvPr id="4" name="Image 0" descr="Screenshot Boss-Startseite einer Epoche: „8 Aufgaben · 25 Minuten · ohne Werkzeuge“, Siegel-Symbol, bester Versuch, Knopf „Boss herausfordern“.">    </p:cNvPr>
+          <p:cNvPicPr>
+            <a:picLocks noChangeAspect="1"/>
+          </p:cNvPicPr>
           <p:nvPr/>
-        </p:nvSpPr>
+        </p:nvPicPr>
+        <p:blipFill>
+          <a:blip r:embed="rId1"/>
+          <a:stretch>
+            <a:fillRect/>
+          </a:stretch>
+        </p:blipFill>
         <p:spPr>
           <a:xfrm>
             <a:off x="548640" y="2429256"/>
-            <a:ext cx="5003597" cy="2926080"/>
-          </a:xfrm>
-          <a:prstGeom prst="rect">
-            <a:avLst/>
-          </a:prstGeom>
-          <a:solidFill>
-            <a:srgbClr val="FFFFFF"/>
-          </a:solidFill>
-          <a:ln w="15875">
-            <a:solidFill>
-              <a:srgbClr val="4A4A55"/>
-            </a:solidFill>
-            <a:prstDash val="dash"/>
-          </a:ln>
-        </p:spPr>
-      </p:sp>
-      <p:sp>
-        <p:nvSpPr>
-          <p:cNvPr id="5" name="Text 3"/>
-          <p:cNvSpPr txBox="1"/>
-          <p:nvPr/>
-        </p:nvSpPr>
-        <p:spPr>
-          <a:xfrm>
-            <a:off x="822960" y="2703576"/>
-            <a:ext cx="4454957" cy="2377440"/>
-          </a:xfrm>
-          <a:prstGeom prst="rect">
-            <a:avLst/>
-          </a:prstGeom>
-          <a:noFill/>
-          <a:ln/>
-        </p:spPr>
-        <p:txBody>
-          <a:bodyPr wrap="square" lIns="0" tIns="0" rIns="0" bIns="0" rtlCol="0" anchor="ctr"/>
-          <a:lstStyle/>
-          <a:p>
-            <a:pPr algn="ctr" indent="0" marL="0">
-              <a:buNone/>
-            </a:pPr>
-            <a:r>
-              <a:rPr lang="en-US" sz="1400" b="1" spc="200" kern="0" dirty="0">
-                <a:solidFill>
-                  <a:srgbClr val="4A4A55"/>
-                </a:solidFill>
-              </a:rPr>
-              <a:t>BILD EINFÜGEN
-</a:t>
-            </a:r>
-            <a:r>
-              <a:rPr lang="en-US" sz="1400" dirty="0">
-                <a:solidFill>
-                  <a:srgbClr val="4A4A55"/>
-                </a:solidFill>
-              </a:rPr>
-              <a:t>Screenshot Boss-Startseite einer Epoche: „8 Aufgaben · 25 Minuten · ohne Werkzeuge“, Siegel-Symbol, bester Versuch, Knopf „Boss herausfordern“.</a:t>
-            </a:r>
-            <a:endParaRPr lang="en-US" sz="1400" dirty="0"/>
-          </a:p>
-        </p:txBody>
-      </p:sp>
-      <p:sp>
-        <p:nvSpPr>
-          <p:cNvPr id="6" name="Shape 4"/>
+            <a:ext cx="5003597" cy="2814523"/>
+          </a:xfrm>
+          <a:prstGeom prst="rect">
+            <a:avLst/>
+          </a:prstGeom>
+        </p:spPr>
+      </p:pic>
+      <p:sp>
+        <p:nvSpPr>
+          <p:cNvPr id="5" name="Shape 2"/>
           <p:cNvSpPr/>
           <p:nvPr/>
         </p:nvSpPr>
@@ -11367,7 +11045,7 @@
       </p:sp>
       <p:sp>
         <p:nvSpPr>
-          <p:cNvPr id="7" name="Text 5"/>
+          <p:cNvPr id="6" name="Text 3"/>
           <p:cNvSpPr txBox="1"/>
           <p:nvPr/>
         </p:nvSpPr>
@@ -11403,7 +11081,7 @@
       </p:sp>
       <p:sp>
         <p:nvSpPr>
-          <p:cNvPr id="8" name="Text 6"/>
+          <p:cNvPr id="7" name="Text 4"/>
           <p:cNvSpPr txBox="1"/>
           <p:nvPr/>
         </p:nvSpPr>
@@ -11455,7 +11133,7 @@
       </p:sp>
       <p:sp>
         <p:nvSpPr>
-          <p:cNvPr id="9" name="Text 7"/>
+          <p:cNvPr id="8" name="Text 5"/>
           <p:cNvSpPr txBox="1"/>
           <p:nvPr/>
         </p:nvSpPr>
@@ -11499,7 +11177,7 @@
       </p:sp>
       <p:sp>
         <p:nvSpPr>
-          <p:cNvPr id="10" name="Text 8"/>
+          <p:cNvPr id="9" name="Text 6"/>
           <p:cNvSpPr txBox="1"/>
           <p:nvPr/>
         </p:nvSpPr>
@@ -11535,7 +11213,7 @@
       </p:sp>
       <p:sp>
         <p:nvSpPr>
-          <p:cNvPr id="11" name="Text 9"/>
+          <p:cNvPr id="10" name="Text 7"/>
           <p:cNvSpPr txBox="1"/>
           <p:nvPr/>
         </p:nvSpPr>

</xml_diff>

<commit_message>
M10: Objektbilder der Labor-Werkzeuge in Folien W0/W2/W3-Kür und Videos 00/01 (L58, Task 240)
Zusatzfolien mit Objektbild und Bildunterschrift „Kryptolabor · Ideen von A. Bodendiek (Krypto-Werkstatt)“: W0 Stab,
Codes & Signale, Schablone, Scheibe; W2 Playfair; W3 Kür Enigma und Stromweg. Video 00 „Werkzeuge zum Anfassen“, Video 01
„Die Chiffrierscheibe im Kryptolabor“ (neues Bild scheibe_leer.png ohne Folienbeispiel), Skript.md ergänzt. kr_pptx.js
setzt Bildunterschriften, video_folien.py nimmt zentrale Bilder unter materialien/; labor_bilder.js lädt je Bild neu.
Präsentationen gebaut (bauen.py mit Quellliste), Lehrkraft-PDFs W0/W2/W3 neu; Test für Namensnennung und Herkunft.

Co-Authored-By: Claude Opus 5.5 <noreply@anthropic.com>
Claude-Session: https://claude.ai/code/session_01JKXVQqFeKVmyQ9jfHw4db3
</commit_message>
<xml_diff>
--- a/materialien/Videos/00_Kryptos_Zeitreise/KR_Video_00_Kryptos_Zeitreise_Folien.pptx
+++ b/materialien/Videos/00_Kryptos_Zeitreise/KR_Video_00_Kryptos_Zeitreise_Folien.pptx
@@ -20,9 +20,10 @@
     <p:sldId id="268" r:id="rId14"/>
     <p:sldId id="269" r:id="rId15"/>
     <p:sldId id="270" r:id="rId16"/>
+    <p:sldId id="271" r:id="rId17"/>
   </p:sldIdLst>
   <p:notesMasterIdLst>
-    <p:notesMasterId r:id="rId17"/>
+    <p:notesMasterId r:id="rId18"/>
   </p:notesMasterIdLst>
   <p:sldSz cx="12192000" cy="6858000"/>
   <p:notesSz cx="6858000" cy="12192000"/>
@@ -121,55 +122,56 @@
   <p:extLst>
     <p:ext uri="{521415D9-36F7-43E2-AB2F-B90AF26B5E84}">
       <p14:sectionLst xmlns:p14="http://schemas.microsoft.com/office/powerpoint/2010/main">
-        <p14:section name="Einstieg" id="{546eaec6-0097-c333-2777-b401db5297e7}">
+        <p14:section name="Einstieg" id="{7019fd08-52b1-789c-3f8b-78e7daafebe5}">
           <p14:sldIdLst>
             <p14:sldId id="256"/>
             <p14:sldId id="257"/>
           </p14:sldIdLst>
         </p14:section>
-        <p14:section name="Anmelden über InfoLabs" id="{7b1fe01d-e478-f826-b2c3-f2890130d614}">
+        <p14:section name="Anmelden über InfoLabs" id="{87970400-5766-80df-2c0f-654139099804}">
           <p14:sldIdLst>
             <p14:sldId id="258"/>
             <p14:sldId id="259"/>
           </p14:sldIdLst>
         </p14:section>
-        <p14:section name="Zeitleiste und Level" id="{0ddaec43-a63c-97ad-4198-cdc4247030cf}">
+        <p14:section name="Zeitleiste und Level" id="{c0b53148-7ada-ebbd-5263-2498fc9b46d5}">
           <p14:sldIdLst>
             <p14:sldId id="260"/>
             <p14:sldId id="261"/>
           </p14:sldIdLst>
         </p14:section>
-        <p14:section name="Punkte und Fallen" id="{1504397a-507d-2c01-fa4b-9e11db4b42df}">
+        <p14:section name="Punkte und Fallen" id="{e71f0674-fa36-6f14-06b4-ffc562af2e30}">
           <p14:sldIdLst>
             <p14:sldId id="262"/>
             <p14:sldId id="263"/>
           </p14:sldIdLst>
         </p14:section>
-        <p14:section name="Boss, Training, Warm-up" id="{09da3bc5-8862-8dcf-4368-a62f455f5e19}">
+        <p14:section name="Boss, Training, Warm-up" id="{cc368a3e-ff43-2760-332a-b2431509701b}">
           <p14:sldIdLst>
             <p14:sldId id="264"/>
           </p14:sldIdLst>
         </p14:section>
-        <p14:section name="Labor und Funkraum" id="{8913e366-a930-f1d9-70ad-fdbfc146dbee}">
+        <p14:section name="Labor und Funkraum" id="{a995c186-8d63-c829-2ea7-d103c491b103}">
           <p14:sldIdLst>
             <p14:sldId id="265"/>
-          </p14:sldIdLst>
-        </p14:section>
-        <p14:section name="Ränge und Artefakte" id="{cfc9eb4f-6dd1-6d67-2e56-ac0fde7cab2f}">
-          <p14:sldIdLst>
             <p14:sldId id="266"/>
           </p14:sldIdLst>
         </p14:section>
-        <p14:section name="Gastmodus" id="{061c7cf8-ac79-59ec-a8a1-c2680914e530}">
+        <p14:section name="Ränge und Artefakte" id="{118f7599-0f0a-f7f5-a3e0-4513b7e67e28}">
           <p14:sldIdLst>
             <p14:sldId id="267"/>
-            <p14:sldId id="268"/>
           </p14:sldIdLst>
         </p14:section>
-        <p14:section name="Zusammenfassung" id="{44efdc7e-ca92-e070-21ca-fd471a852dc3}">
+        <p14:section name="Gastmodus" id="{6cbc15d8-2076-dda9-0be2-bcf490cb2652}">
           <p14:sldIdLst>
+            <p14:sldId id="268"/>
             <p14:sldId id="269"/>
+          </p14:sldIdLst>
+        </p14:section>
+        <p14:section name="Zusammenfassung" id="{160ea641-196e-abc1-97c7-0360f4d3c7e2}">
+          <p14:sldIdLst>
             <p14:sldId id="270"/>
+            <p14:sldId id="271"/>
           </p14:sldIdLst>
         </p14:section>
       </p14:sectionLst>
@@ -756,9 +758,9 @@
           <a:p>
             <a:r>
               <a:rPr lang="en-US" dirty="0"/>
-              <a:t>[Kapitel: Ränge und Artefakte]
-REGIE: Auf die genannten Bildteile zeigen; Kasten rechts nach dem ersten Satz einblenden.
-SPRECHERTEXT: Mit deinen Punkten steigst du auf – vom Lehrling bis zum Meister der Chiffren. Jeder besiegte Boss bringt ein Artefakt, von der Skytale bis zum Kern des Chronoskops. Und auf der Zeitleiste entsiegelt sich mit jeder Epoche ein Kapitel Kryptogeschichte.</a:t>
+              <a:t>[Kapitel: Labor und Funkraum]
+REGIE: Auf Quadrat und Panel zeigen; Kasten rechts nach dem zweiten Satz einblenden.
+SPRECHERTEXT: Viele Werkzeuge im Kryptolabor sind Objekte zum Anfassen: das Polybios-Quadrat, die Skytale, die Chiffrierscheibe oder die Enigma. Du tippst direkt auf das Objekt, und mit Nachspielen siehst du jeden Schritt noch einmal in Ruhe. Die Ideen dafür stammen aus der Krypto-Werkstatt von A. Bodendiek.</a:t>
             </a:r>
             <a:endParaRPr lang="en-US" dirty="0"/>
           </a:p>
@@ -846,9 +848,9 @@
           <a:p>
             <a:r>
               <a:rPr lang="en-US" dirty="0"/>
-              <a:t>[Kapitel: Gastmodus]
-REGIE: Stichpunkte nacheinander einblenden, den Kasten rechts zum Schluss.
-SPRECHERTEXT: Noch kein Kurscode? Im Gastmodus unter kryptos punkt frankjuchim punkt de Schrägstrich gast probierst du sechs Demo-Aufgaben ohne Anmeldung aus. Gespeichert wird dort nichts.</a:t>
+              <a:t>[Kapitel: Ränge und Artefakte]
+REGIE: Auf die genannten Bildteile zeigen; Kasten rechts nach dem ersten Satz einblenden.
+SPRECHERTEXT: Mit deinen Punkten steigst du auf – vom Lehrling bis zum Meister der Chiffren. Jeder besiegte Boss bringt ein Artefakt, von der Skytale bis zum Kern des Chronoskops. Und auf der Zeitleiste entsiegelt sich mit jeder Epoche ein Kapitel Kryptogeschichte.</a:t>
             </a:r>
             <a:endParaRPr lang="en-US" dirty="0"/>
           </a:p>
@@ -936,9 +938,9 @@
           <a:p>
             <a:r>
               <a:rPr lang="en-US" dirty="0"/>
-              <a:t>REGIE: Einblendung „⏸ Video anhalten“.
-SPRECHERTEXT: Jetzt du: Halte das Video an, melde dich an und notiere deinen Code. Dann weiter zu Kryptos, in die Antike und zur ersten Aufgabe in Level null Punkt eins.
-PAUSE: 3 s Einblendung „⏸ Video anhalten“</a:t>
+              <a:t>[Kapitel: Gastmodus]
+REGIE: Stichpunkte nacheinander einblenden, den Kasten rechts zum Schluss.
+SPRECHERTEXT: Noch kein Kurscode? Im Gastmodus unter kryptos punkt frankjuchim punkt de Schrägstrich gast probierst du sechs Demo-Aufgaben ohne Anmeldung aus. Gespeichert wird dort nichts.</a:t>
             </a:r>
             <a:endParaRPr lang="en-US" dirty="0"/>
           </a:p>
@@ -1026,9 +1028,9 @@
           <a:p>
             <a:r>
               <a:rPr lang="en-US" dirty="0"/>
-              <a:t>[Kapitel: Zusammenfassung]
-REGIE: Merksätze nacheinander einblenden; ruhig und etwas langsamer sprechen.
-SPRECHERTEXT: Kurz gesagt: anmelden über InfoLabs, Code notieren, weiter zu Kryptos. Tipps und Fehlversuche kosten etwas, die Fallen zeigen dir deine Stolpersteine, und jede Epoche endet mit einem Boss.</a:t>
+              <a:t>REGIE: Einblendung „⏸ Video anhalten“.
+SPRECHERTEXT: Jetzt du: Halte das Video an, melde dich an und notiere deinen Code. Dann weiter zu Kryptos, in die Antike und zur ersten Aufgabe in Level null Punkt eins.
+PAUSE: 3 s Einblendung „⏸ Video anhalten“</a:t>
             </a:r>
             <a:endParaRPr lang="en-US" dirty="0"/>
           </a:p>
@@ -1116,8 +1118,9 @@
           <a:p>
             <a:r>
               <a:rPr lang="en-US" dirty="0"/>
-              <a:t>REGIE: Endcard über die letzten 20 s legen.
-SPRECHERTEXT: Deine erste Station ist Level null Punkt eins, die Skytale von Sparta. Im nächsten Video geht es um Caesar, das Alphabet und das Rechnen mit Modulo. Gute Reise durch die Zeit – wir sehen uns im Archiv!</a:t>
+              <a:t>[Kapitel: Zusammenfassung]
+REGIE: Merksätze nacheinander einblenden; ruhig und etwas langsamer sprechen.
+SPRECHERTEXT: Kurz gesagt: anmelden über InfoLabs, Code notieren, weiter zu Kryptos. Tipps und Fehlversuche kosten etwas, die Fallen zeigen dir deine Stolpersteine, und jede Epoche endet mit einem Boss.</a:t>
             </a:r>
             <a:endParaRPr lang="en-US" dirty="0"/>
           </a:p>
@@ -1141,6 +1144,95 @@
             <a:fld id="{F7021451-1387-4CA6-816F-3879F97B5CBC}" type="slidenum">
               <a:rPr lang="en-US"/>
               <a:t>15</a:t>
+            </a:fld>
+            <a:endParaRPr lang="en-US"/>
+          </a:p>
+        </p:txBody>
+      </p:sp>
+    </p:spTree>
+    <p:extLst>
+      <p:ext uri="{BB962C8B-B14F-4D97-AF65-F5344CB8AC3E}">
+        <p14:creationId xmlns:p14="http://schemas.microsoft.com/office/powerpoint/2010/main" val="1024086991"/>
+      </p:ext>
+    </p:extLst>
+  </p:cSld>
+  <p:clrMapOvr>
+    <a:masterClrMapping/>
+  </p:clrMapOvr>
+</p:notes>
+</file>
+
+<file path=ppt/notesSlides/notesSlide16.xml><?xml version="1.0" encoding="utf-8"?>
+<p:notes xmlns:a="http://schemas.openxmlformats.org/drawingml/2006/main" xmlns:r="http://schemas.openxmlformats.org/officeDocument/2006/relationships" xmlns:p="http://schemas.openxmlformats.org/presentationml/2006/main">
+  <p:cSld>
+    <p:spTree>
+      <p:nvGrpSpPr>
+        <p:cNvPr id="1" name=""/>
+        <p:cNvGrpSpPr/>
+        <p:nvPr/>
+      </p:nvGrpSpPr>
+      <p:grpSpPr>
+        <a:xfrm>
+          <a:off x="0" y="0"/>
+          <a:ext cx="0" cy="0"/>
+          <a:chOff x="0" y="0"/>
+          <a:chExt cx="0" cy="0"/>
+        </a:xfrm>
+      </p:grpSpPr>
+      <p:sp>
+        <p:nvSpPr>
+          <p:cNvPr id="2" name="Slide Image Placeholder 1"/>
+          <p:cNvSpPr>
+            <a:spLocks noGrp="1" noRot="1" noChangeAspect="1"/>
+          </p:cNvSpPr>
+          <p:nvPr>
+            <p:ph type="sldImg"/>
+          </p:nvPr>
+        </p:nvSpPr>
+        <p:spPr/>
+      </p:sp>
+      <p:sp>
+        <p:nvSpPr>
+          <p:cNvPr id="3" name="Notes Placeholder 2"/>
+          <p:cNvSpPr>
+            <a:spLocks noGrp="1"/>
+          </p:cNvSpPr>
+          <p:nvPr>
+            <p:ph type="body" idx="1"/>
+          </p:nvPr>
+        </p:nvSpPr>
+        <p:spPr/>
+        <p:txBody>
+          <a:bodyPr/>
+          <a:lstStyle/>
+          <a:p>
+            <a:r>
+              <a:rPr lang="en-US" dirty="0"/>
+              <a:t>REGIE: Endcard über die letzten 20 s legen.
+SPRECHERTEXT: Deine erste Station ist Level null Punkt eins, die Skytale von Sparta. Im nächsten Video geht es um Caesar, das Alphabet und das Rechnen mit Modulo. Gute Reise durch die Zeit – wir sehen uns im Archiv!</a:t>
+            </a:r>
+            <a:endParaRPr lang="en-US" dirty="0"/>
+          </a:p>
+        </p:txBody>
+      </p:sp>
+      <p:sp>
+        <p:nvSpPr>
+          <p:cNvPr id="4" name="Slide Number Placeholder 3"/>
+          <p:cNvSpPr>
+            <a:spLocks noGrp="1"/>
+          </p:cNvSpPr>
+          <p:nvPr>
+            <p:ph type="sldNum" sz="quarter" idx="10"/>
+          </p:nvPr>
+        </p:nvSpPr>
+        <p:spPr/>
+        <p:txBody>
+          <a:bodyPr/>
+          <a:lstStyle/>
+          <a:p>
+            <a:fld id="{F7021451-1387-4CA6-816F-3879F97B5CBC}" type="slidenum">
+              <a:rPr lang="en-US"/>
+              <a:t>16</a:t>
             </a:fld>
             <a:endParaRPr lang="en-US"/>
           </a:p>
@@ -3483,7 +3575,7 @@
                 <a:ea typeface="Georgia" pitchFamily="34" charset="-122"/>
                 <a:cs typeface="Georgia" pitchFamily="34" charset="-120"/>
               </a:rPr>
-              <a:t>Ränge, Artefakte, Abzeichen</a:t>
+              <a:t>Werkzeuge zum Anfassen</a:t>
             </a:r>
             <a:endParaRPr lang="en-US" sz="3000" dirty="0"/>
           </a:p>
@@ -3491,7 +3583,7 @@
       </p:sp>
       <p:pic>
         <p:nvPicPr>
-          <p:cNvPr id="3" name="Image 0" descr="Screenshot Profil: Rang-Abzeichen, Punkte, Reihe der sieben Artefakte (Skytale bis Chronoskop-Kern, gesperrte als Umriss), Abzeichen, Radar „Deine Fallen“ P1–P10.">    </p:cNvPr>
+          <p:cNvPr id="3" name="Image 0" descr="Kryptolabor, Werkzeug „Polybios &amp; Playfair“: Polybios-Quadrat auf Papier mit Ziffernköpfen, daneben das Panel „Aktueller Buchstabe“ mit Zahlenpaar; unten rechts die Namensnennung.">    </p:cNvPr>
           <p:cNvPicPr>
             <a:picLocks noChangeAspect="1"/>
           </p:cNvPicPr>
@@ -3515,14 +3607,50 @@
       </p:pic>
       <p:sp>
         <p:nvSpPr>
-          <p:cNvPr id="4" name="Shape 1"/>
+          <p:cNvPr id="4" name="Text 1"/>
+          <p:cNvSpPr txBox="1"/>
+          <p:nvPr/>
+        </p:nvSpPr>
+        <p:spPr>
+          <a:xfrm>
+            <a:off x="548640" y="4176979"/>
+            <a:ext cx="5003597" cy="274320"/>
+          </a:xfrm>
+          <a:prstGeom prst="rect">
+            <a:avLst/>
+          </a:prstGeom>
+          <a:noFill/>
+          <a:ln/>
+        </p:spPr>
+        <p:txBody>
+          <a:bodyPr wrap="square" lIns="0" tIns="0" rIns="0" bIns="0" rtlCol="0" anchor="ctr"/>
+          <a:lstStyle/>
+          <a:p>
+            <a:pPr algn="ctr" indent="0" marL="0">
+              <a:buNone/>
+            </a:pPr>
+            <a:r>
+              <a:rPr lang="en-US" sz="1200" i="1" dirty="0">
+                <a:solidFill>
+                  <a:srgbClr val="4A4A55"/>
+                </a:solidFill>
+              </a:rPr>
+              <a:t>Kryptolabor · Ideen von A. Bodendiek (Krypto-Werkstatt)</a:t>
+            </a:r>
+            <a:endParaRPr lang="en-US" sz="1200" dirty="0"/>
+          </a:p>
+        </p:txBody>
+      </p:sp>
+      <p:sp>
+        <p:nvSpPr>
+          <p:cNvPr id="5" name="Shape 2"/>
           <p:cNvSpPr/>
           <p:nvPr/>
         </p:nvSpPr>
         <p:spPr>
           <a:xfrm>
             <a:off x="5917997" y="1325880"/>
-            <a:ext cx="1945843" cy="3284728"/>
+            <a:ext cx="1945843" cy="3594608"/>
           </a:xfrm>
           <a:prstGeom prst="roundRect">
             <a:avLst>
@@ -3542,7 +3670,7 @@
       </p:sp>
       <p:sp>
         <p:nvSpPr>
-          <p:cNvPr id="5" name="Text 2"/>
+          <p:cNvPr id="6" name="Text 3"/>
           <p:cNvSpPr txBox="1"/>
           <p:nvPr/>
         </p:nvSpPr>
@@ -3570,7 +3698,7 @@
                   <a:srgbClr val="8A5F1A"/>
                 </a:solidFill>
               </a:rPr>
-              <a:t>RÄNGE</a:t>
+              <a:t>AM OBJEKT</a:t>
             </a:r>
             <a:endParaRPr lang="en-US" sz="1300" dirty="0"/>
           </a:p>
@@ -3578,14 +3706,14 @@
       </p:sp>
       <p:sp>
         <p:nvSpPr>
-          <p:cNvPr id="6" name="Text 3"/>
+          <p:cNvPr id="7" name="Text 4"/>
           <p:cNvSpPr txBox="1"/>
           <p:nvPr/>
         </p:nvSpPr>
         <p:spPr>
           <a:xfrm>
             <a:off x="6146597" y="1783080"/>
-            <a:ext cx="1488643" cy="665480"/>
+            <a:ext cx="1488643" cy="975360"/>
           </a:xfrm>
           <a:prstGeom prst="rect">
             <a:avLst/>
@@ -3606,7 +3734,7 @@
                   <a:srgbClr val="1B1B1F"/>
                 </a:solidFill>
               </a:rPr>
-              <a:t>Lehrling → Schreiber</a:t>
+              <a:t>direkt antippen und drehen</a:t>
             </a:r>
             <a:endParaRPr lang="en-US" sz="2000" dirty="0"/>
           </a:p>
@@ -3614,13 +3742,13 @@
       </p:sp>
       <p:sp>
         <p:nvSpPr>
-          <p:cNvPr id="7" name="Text 4"/>
+          <p:cNvPr id="8" name="Text 5"/>
           <p:cNvSpPr txBox="1"/>
           <p:nvPr/>
         </p:nvSpPr>
         <p:spPr>
           <a:xfrm>
-            <a:off x="6146597" y="2576576"/>
+            <a:off x="6146597" y="2886456"/>
             <a:ext cx="1488643" cy="975360"/>
           </a:xfrm>
           <a:prstGeom prst="rect">
@@ -3642,7 +3770,7 @@
                   <a:srgbClr val="1B1B1F"/>
                 </a:solidFill>
               </a:rPr>
-              <a:t>→ Chiffreur → Kryptoanalytiker</a:t>
+              <a:t>Nachspielen Schritt für Schritt</a:t>
             </a:r>
             <a:endParaRPr lang="en-US" sz="2000" dirty="0"/>
           </a:p>
@@ -3650,13 +3778,13 @@
       </p:sp>
       <p:sp>
         <p:nvSpPr>
-          <p:cNvPr id="8" name="Text 5"/>
+          <p:cNvPr id="9" name="Text 6"/>
           <p:cNvSpPr txBox="1"/>
           <p:nvPr/>
         </p:nvSpPr>
         <p:spPr>
           <a:xfrm>
-            <a:off x="6146597" y="3679952"/>
+            <a:off x="6146597" y="3989832"/>
             <a:ext cx="1488643" cy="665480"/>
           </a:xfrm>
           <a:prstGeom prst="rect">
@@ -3678,15 +3806,7 @@
                   <a:srgbClr val="1B1B1F"/>
                 </a:solidFill>
               </a:rPr>
-              <a:t>→ </a:t>
-            </a:r>
-            <a:r>
-              <a:rPr lang="en-US" sz="2000" b="1" dirty="0">
-                <a:solidFill>
-                  <a:srgbClr val="1B1B1F"/>
-                </a:solidFill>
-              </a:rPr>
-              <a:t>Meister der Chiffren</a:t>
+              <a:t>Ideen von A. Bodendiek</a:t>
             </a:r>
             <a:endParaRPr lang="en-US" sz="2000" dirty="0"/>
           </a:p>
@@ -3797,22 +3917,73 @@
                 <a:ea typeface="Georgia" pitchFamily="34" charset="-122"/>
                 <a:cs typeface="Georgia" pitchFamily="34" charset="-120"/>
               </a:rPr>
-              <a:t>Gastmodus: ohne Anmeldung reinschnuppern</a:t>
+              <a:t>Ränge, Artefakte, Abzeichen</a:t>
             </a:r>
             <a:endParaRPr lang="en-US" sz="3000" dirty="0"/>
           </a:p>
         </p:txBody>
       </p:sp>
-      <p:sp>
-        <p:nvSpPr>
-          <p:cNvPr id="3" name="Text 1"/>
+      <p:pic>
+        <p:nvPicPr>
+          <p:cNvPr id="3" name="Image 0" descr="Screenshot Profil: Rang-Abzeichen, Punkte, Reihe der sieben Artefakte (Skytale bis Chronoskop-Kern, gesperrte als Umriss), Abzeichen, Radar „Deine Fallen“ P1–P10.">    </p:cNvPr>
+          <p:cNvPicPr>
+            <a:picLocks noChangeAspect="1"/>
+          </p:cNvPicPr>
+          <p:nvPr/>
+        </p:nvPicPr>
+        <p:blipFill>
+          <a:blip r:embed="rId1"/>
+          <a:stretch>
+            <a:fillRect/>
+          </a:stretch>
+        </p:blipFill>
+        <p:spPr>
+          <a:xfrm>
+            <a:off x="548640" y="1325880"/>
+            <a:ext cx="5003597" cy="2814523"/>
+          </a:xfrm>
+          <a:prstGeom prst="rect">
+            <a:avLst/>
+          </a:prstGeom>
+        </p:spPr>
+      </p:pic>
+      <p:sp>
+        <p:nvSpPr>
+          <p:cNvPr id="4" name="Shape 1"/>
+          <p:cNvSpPr/>
+          <p:nvPr/>
+        </p:nvSpPr>
+        <p:spPr>
+          <a:xfrm>
+            <a:off x="5917997" y="1325880"/>
+            <a:ext cx="1945843" cy="3284728"/>
+          </a:xfrm>
+          <a:prstGeom prst="roundRect">
+            <a:avLst>
+              <a:gd name="adj" fmla="val 3759"/>
+            </a:avLst>
+          </a:prstGeom>
+          <a:solidFill>
+            <a:srgbClr val="FBF3E2"/>
+          </a:solidFill>
+          <a:ln w="12700">
+            <a:solidFill>
+              <a:srgbClr val="8A5F1A"/>
+            </a:solidFill>
+            <a:prstDash val="solid"/>
+          </a:ln>
+        </p:spPr>
+      </p:sp>
+      <p:sp>
+        <p:nvSpPr>
+          <p:cNvPr id="5" name="Text 2"/>
           <p:cNvSpPr txBox="1"/>
           <p:nvPr/>
         </p:nvSpPr>
         <p:spPr>
           <a:xfrm>
-            <a:off x="548640" y="1325880"/>
-            <a:ext cx="7315200" cy="1738376"/>
+            <a:off x="6146597" y="1435608"/>
+            <a:ext cx="1488643" cy="274320"/>
           </a:xfrm>
           <a:prstGeom prst="rect">
             <a:avLst/>
@@ -3821,79 +3992,137 @@
           <a:ln/>
         </p:spPr>
         <p:txBody>
+          <a:bodyPr wrap="square" lIns="0" tIns="0" rIns="0" bIns="0" rtlCol="0" anchor="ctr"/>
+          <a:lstStyle/>
+          <a:p>
+            <a:pPr indent="0" marL="0">
+              <a:buNone/>
+            </a:pPr>
+            <a:r>
+              <a:rPr lang="en-US" sz="1300" b="1" spc="200" kern="0" dirty="0">
+                <a:solidFill>
+                  <a:srgbClr val="8A5F1A"/>
+                </a:solidFill>
+              </a:rPr>
+              <a:t>RÄNGE</a:t>
+            </a:r>
+            <a:endParaRPr lang="en-US" sz="1300" dirty="0"/>
+          </a:p>
+        </p:txBody>
+      </p:sp>
+      <p:sp>
+        <p:nvSpPr>
+          <p:cNvPr id="6" name="Text 3"/>
+          <p:cNvSpPr txBox="1"/>
+          <p:nvPr/>
+        </p:nvSpPr>
+        <p:spPr>
+          <a:xfrm>
+            <a:off x="6146597" y="1783080"/>
+            <a:ext cx="1488643" cy="665480"/>
+          </a:xfrm>
+          <a:prstGeom prst="rect">
+            <a:avLst/>
+          </a:prstGeom>
+          <a:noFill/>
+          <a:ln/>
+        </p:spPr>
+        <p:txBody>
           <a:bodyPr wrap="square" lIns="0" tIns="0" rIns="0" bIns="0" rtlCol="0" anchor="t"/>
           <a:lstStyle/>
           <a:p>
-            <a:pPr marL="279400" indent="-279400">
-              <a:spcAft>
-                <a:spcPts val="600"/>
-              </a:spcAft>
-              <a:buSzPct val="100000"/>
-              <a:buChar char="●"/>
+            <a:pPr algn="l" indent="0" marL="0">
+              <a:buNone/>
             </a:pPr>
             <a:r>
-              <a:rPr lang="en-US" sz="2200" b="1" dirty="0">
+              <a:rPr lang="en-US" sz="2000" dirty="0">
                 <a:solidFill>
                   <a:srgbClr val="1B1B1F"/>
                 </a:solidFill>
               </a:rPr>
-              <a:t>kryptos.frankjuchim.de/gast</a:t>
-            </a:r>
-            <a:endParaRPr lang="en-US" sz="2200" dirty="0"/>
-          </a:p>
-          <a:p>
-            <a:pPr marL="279400" indent="-279400">
-              <a:spcAft>
-                <a:spcPts val="600"/>
-              </a:spcAft>
-              <a:buSzPct val="100000"/>
-              <a:buChar char="●"/>
+              <a:t>Lehrling → Schreiber</a:t>
+            </a:r>
+            <a:endParaRPr lang="en-US" sz="2000" dirty="0"/>
+          </a:p>
+        </p:txBody>
+      </p:sp>
+      <p:sp>
+        <p:nvSpPr>
+          <p:cNvPr id="7" name="Text 4"/>
+          <p:cNvSpPr txBox="1"/>
+          <p:nvPr/>
+        </p:nvSpPr>
+        <p:spPr>
+          <a:xfrm>
+            <a:off x="6146597" y="2576576"/>
+            <a:ext cx="1488643" cy="975360"/>
+          </a:xfrm>
+          <a:prstGeom prst="rect">
+            <a:avLst/>
+          </a:prstGeom>
+          <a:noFill/>
+          <a:ln/>
+        </p:spPr>
+        <p:txBody>
+          <a:bodyPr wrap="square" lIns="0" tIns="0" rIns="0" bIns="0" rtlCol="0" anchor="t"/>
+          <a:lstStyle/>
+          <a:p>
+            <a:pPr algn="l" indent="0" marL="0">
+              <a:buNone/>
             </a:pPr>
             <a:r>
-              <a:rPr lang="en-US" sz="2200" dirty="0">
+              <a:rPr lang="en-US" sz="2000" dirty="0">
                 <a:solidFill>
                   <a:srgbClr val="1B1B1F"/>
                 </a:solidFill>
               </a:rPr>
-              <a:t>6 Demo-Aufgaben und die Chiffrierscheibe</a:t>
-            </a:r>
-            <a:endParaRPr lang="en-US" sz="2200" dirty="0"/>
-          </a:p>
-          <a:p>
-            <a:pPr marL="279400" indent="-279400">
-              <a:spcAft>
-                <a:spcPts val="600"/>
-              </a:spcAft>
-              <a:buSzPct val="100000"/>
-              <a:buChar char="●"/>
+              <a:t>→ Chiffreur → Kryptoanalytiker</a:t>
+            </a:r>
+            <a:endParaRPr lang="en-US" sz="2000" dirty="0"/>
+          </a:p>
+        </p:txBody>
+      </p:sp>
+      <p:sp>
+        <p:nvSpPr>
+          <p:cNvPr id="8" name="Text 5"/>
+          <p:cNvSpPr txBox="1"/>
+          <p:nvPr/>
+        </p:nvSpPr>
+        <p:spPr>
+          <a:xfrm>
+            <a:off x="6146597" y="3679952"/>
+            <a:ext cx="1488643" cy="665480"/>
+          </a:xfrm>
+          <a:prstGeom prst="rect">
+            <a:avLst/>
+          </a:prstGeom>
+          <a:noFill/>
+          <a:ln/>
+        </p:spPr>
+        <p:txBody>
+          <a:bodyPr wrap="square" lIns="0" tIns="0" rIns="0" bIns="0" rtlCol="0" anchor="t"/>
+          <a:lstStyle/>
+          <a:p>
+            <a:pPr algn="l" indent="0" marL="0">
+              <a:buNone/>
             </a:pPr>
             <a:r>
-              <a:rPr lang="en-US" sz="2200" dirty="0">
+              <a:rPr lang="en-US" sz="2000" dirty="0">
                 <a:solidFill>
                   <a:srgbClr val="1B1B1F"/>
                 </a:solidFill>
               </a:rPr>
-              <a:t>Nichts wird gespeichert</a:t>
-            </a:r>
-            <a:endParaRPr lang="en-US" sz="2200" dirty="0"/>
-          </a:p>
-          <a:p>
-            <a:pPr marL="279400" indent="-279400">
-              <a:spcAft>
-                <a:spcPts val="600"/>
-              </a:spcAft>
-              <a:buSzPct val="100000"/>
-              <a:buChar char="●"/>
-            </a:pPr>
-            <a:r>
-              <a:rPr lang="en-US" sz="2200" dirty="0">
+              <a:t>→ </a:t>
+            </a:r>
+            <a:r>
+              <a:rPr lang="en-US" sz="2000" b="1" dirty="0">
                 <a:solidFill>
                   <a:srgbClr val="1B1B1F"/>
                 </a:solidFill>
               </a:rPr>
-              <a:t>Für Lehrkräfte: ein erfundener Demo-Kurs</a:t>
-            </a:r>
-            <a:endParaRPr lang="en-US" sz="2200" dirty="0"/>
+              <a:t>Meister der Chiffren</a:t>
+            </a:r>
+            <a:endParaRPr lang="en-US" sz="2000" dirty="0"/>
           </a:p>
         </p:txBody>
       </p:sp>
@@ -4002,7 +4231,7 @@
                 <a:ea typeface="Georgia" pitchFamily="34" charset="-122"/>
                 <a:cs typeface="Georgia" pitchFamily="34" charset="-120"/>
               </a:rPr>
-              <a:t>Probier es aus!</a:t>
+              <a:t>Gastmodus: ohne Anmeldung reinschnuppern</a:t>
             </a:r>
             <a:endParaRPr lang="en-US" sz="3000" dirty="0"/>
           </a:p>
@@ -4017,121 +4246,7 @@
         <p:spPr>
           <a:xfrm>
             <a:off x="548640" y="1325880"/>
-            <a:ext cx="1463040" cy="384048"/>
-          </a:xfrm>
-          <a:prstGeom prst="rect">
-            <a:avLst/>
-          </a:prstGeom>
-          <a:solidFill>
-            <a:srgbClr val="8A5F1A"/>
-          </a:solidFill>
-          <a:ln/>
-        </p:spPr>
-        <p:txBody>
-          <a:bodyPr wrap="square" lIns="0" tIns="0" rIns="0" bIns="0" rtlCol="0" anchor="ctr"/>
-          <a:lstStyle/>
-          <a:p>
-            <a:pPr algn="ctr" indent="0" marL="0">
-              <a:buNone/>
-            </a:pPr>
-            <a:r>
-              <a:rPr lang="en-US" sz="1400" b="1" spc="300" kern="0" dirty="0">
-                <a:solidFill>
-                  <a:srgbClr val="FFFFFF"/>
-                </a:solidFill>
-              </a:rPr>
-              <a:t>AUFTRAG</a:t>
-            </a:r>
-            <a:endParaRPr lang="en-US" sz="1400" dirty="0"/>
-          </a:p>
-        </p:txBody>
-      </p:sp>
-      <p:sp>
-        <p:nvSpPr>
-          <p:cNvPr id="4" name="Text 2"/>
-          <p:cNvSpPr txBox="1"/>
-          <p:nvPr/>
-        </p:nvSpPr>
-        <p:spPr>
-          <a:xfrm>
-            <a:off x="2148840" y="1325880"/>
-            <a:ext cx="2075688" cy="384048"/>
-          </a:xfrm>
-          <a:prstGeom prst="rect">
-            <a:avLst/>
-          </a:prstGeom>
-          <a:solidFill>
-            <a:srgbClr val="F2EADB"/>
-          </a:solidFill>
-          <a:ln/>
-        </p:spPr>
-        <p:txBody>
-          <a:bodyPr wrap="square" lIns="0" tIns="0" rIns="0" bIns="0" rtlCol="0" anchor="ctr"/>
-          <a:lstStyle/>
-          <a:p>
-            <a:pPr algn="ctr" indent="0" marL="0">
-              <a:buNone/>
-            </a:pPr>
-            <a:r>
-              <a:rPr lang="en-US" sz="1400" dirty="0">
-                <a:solidFill>
-                  <a:srgbClr val="1B1B1F"/>
-                </a:solidFill>
-              </a:rPr>
-              <a:t>⏸ Video anhalten</a:t>
-            </a:r>
-            <a:endParaRPr lang="en-US" sz="1400" dirty="0"/>
-          </a:p>
-        </p:txBody>
-      </p:sp>
-      <p:sp>
-        <p:nvSpPr>
-          <p:cNvPr id="5" name="Text 3"/>
-          <p:cNvSpPr txBox="1"/>
-          <p:nvPr/>
-        </p:nvSpPr>
-        <p:spPr>
-          <a:xfrm>
-            <a:off x="4361688" y="1325880"/>
-            <a:ext cx="2075688" cy="384048"/>
-          </a:xfrm>
-          <a:prstGeom prst="rect">
-            <a:avLst/>
-          </a:prstGeom>
-          <a:solidFill>
-            <a:srgbClr val="F2EADB"/>
-          </a:solidFill>
-          <a:ln/>
-        </p:spPr>
-        <p:txBody>
-          <a:bodyPr wrap="square" lIns="0" tIns="0" rIns="0" bIns="0" rtlCol="0" anchor="ctr"/>
-          <a:lstStyle/>
-          <a:p>
-            <a:pPr algn="ctr" indent="0" marL="0">
-              <a:buNone/>
-            </a:pPr>
-            <a:r>
-              <a:rPr lang="en-US" sz="1400" dirty="0">
-                <a:solidFill>
-                  <a:srgbClr val="1B1B1F"/>
-                </a:solidFill>
-              </a:rPr>
-              <a:t>selbst probieren</a:t>
-            </a:r>
-            <a:endParaRPr lang="en-US" sz="1400" dirty="0"/>
-          </a:p>
-        </p:txBody>
-      </p:sp>
-      <p:sp>
-        <p:nvSpPr>
-          <p:cNvPr id="6" name="Text 4"/>
-          <p:cNvSpPr txBox="1"/>
-          <p:nvPr/>
-        </p:nvSpPr>
-        <p:spPr>
-          <a:xfrm>
-            <a:off x="548640" y="1965960"/>
-            <a:ext cx="4308653" cy="2090928"/>
+            <a:ext cx="7315200" cy="1738376"/>
           </a:xfrm>
           <a:prstGeom prst="rect">
             <a:avLst/>
@@ -4143,237 +4258,76 @@
           <a:bodyPr wrap="square" lIns="0" tIns="0" rIns="0" bIns="0" rtlCol="0" anchor="t"/>
           <a:lstStyle/>
           <a:p>
-            <a:pPr algn="l" indent="0" marL="0">
-              <a:buNone/>
+            <a:pPr marL="279400" indent="-279400">
+              <a:spcAft>
+                <a:spcPts val="600"/>
+              </a:spcAft>
+              <a:buSzPct val="100000"/>
+              <a:buChar char="●"/>
             </a:pPr>
             <a:r>
+              <a:rPr lang="en-US" sz="2200" b="1" dirty="0">
+                <a:solidFill>
+                  <a:srgbClr val="1B1B1F"/>
+                </a:solidFill>
+              </a:rPr>
+              <a:t>kryptos.frankjuchim.de/gast</a:t>
+            </a:r>
+            <a:endParaRPr lang="en-US" sz="2200" dirty="0"/>
+          </a:p>
+          <a:p>
+            <a:pPr marL="279400" indent="-279400">
+              <a:spcAft>
+                <a:spcPts val="600"/>
+              </a:spcAft>
+              <a:buSzPct val="100000"/>
+              <a:buChar char="●"/>
+            </a:pPr>
+            <a:r>
               <a:rPr lang="en-US" sz="2200" dirty="0">
                 <a:solidFill>
                   <a:srgbClr val="1B1B1F"/>
                 </a:solidFill>
               </a:rPr>
-              <a:t>Melde dich im Portal an und </a:t>
-            </a:r>
-            <a:r>
-              <a:rPr lang="en-US" sz="2200" b="1" dirty="0">
+              <a:t>6 Demo-Aufgaben und die Chiffrierscheibe</a:t>
+            </a:r>
+            <a:endParaRPr lang="en-US" sz="2200" dirty="0"/>
+          </a:p>
+          <a:p>
+            <a:pPr marL="279400" indent="-279400">
+              <a:spcAft>
+                <a:spcPts val="600"/>
+              </a:spcAft>
+              <a:buSzPct val="100000"/>
+              <a:buChar char="●"/>
+            </a:pPr>
+            <a:r>
+              <a:rPr lang="en-US" sz="2200" dirty="0">
                 <a:solidFill>
                   <a:srgbClr val="1B1B1F"/>
                 </a:solidFill>
               </a:rPr>
-              <a:t>notiere deinen persönlichen Code</a:t>
-            </a:r>
+              <a:t>Nichts wird gespeichert</a:t>
+            </a:r>
+            <a:endParaRPr lang="en-US" sz="2200" dirty="0"/>
+          </a:p>
+          <a:p>
+            <a:pPr marL="279400" indent="-279400">
+              <a:spcAft>
+                <a:spcPts val="600"/>
+              </a:spcAft>
+              <a:buSzPct val="100000"/>
+              <a:buChar char="●"/>
+            </a:pPr>
             <a:r>
               <a:rPr lang="en-US" sz="2200" dirty="0">
                 <a:solidFill>
                   <a:srgbClr val="1B1B1F"/>
                 </a:solidFill>
               </a:rPr>
-              <a:t>. Wechsle mit „Weiter zu Kryptos“ in die Plattform, öffne die Epoche </a:t>
-            </a:r>
-            <a:r>
-              <a:rPr lang="en-US" sz="2200" b="1" dirty="0">
-                <a:solidFill>
-                  <a:srgbClr val="1B1B1F"/>
-                </a:solidFill>
-              </a:rPr>
-              <a:t>Antike</a:t>
-            </a:r>
-            <a:r>
-              <a:rPr lang="en-US" sz="2200" dirty="0">
-                <a:solidFill>
-                  <a:srgbClr val="1B1B1F"/>
-                </a:solidFill>
-              </a:rPr>
-              <a:t> und löse die erste Aufgabe in </a:t>
-            </a:r>
-            <a:r>
-              <a:rPr lang="en-US" sz="2200" b="1" dirty="0">
-                <a:solidFill>
-                  <a:srgbClr val="1B1B1F"/>
-                </a:solidFill>
-              </a:rPr>
-              <a:t>Level 0.1</a:t>
-            </a:r>
-            <a:r>
-              <a:rPr lang="en-US" sz="2200" dirty="0">
-                <a:solidFill>
-                  <a:srgbClr val="1B1B1F"/>
-                </a:solidFill>
-              </a:rPr>
-              <a:t>.</a:t>
+              <a:t>Für Lehrkräfte: ein erfundener Demo-Kurs</a:t>
             </a:r>
             <a:endParaRPr lang="en-US" sz="2200" dirty="0"/>
-          </a:p>
-        </p:txBody>
-      </p:sp>
-      <p:sp>
-        <p:nvSpPr>
-          <p:cNvPr id="7" name="Shape 5"/>
-          <p:cNvSpPr/>
-          <p:nvPr/>
-        </p:nvSpPr>
-        <p:spPr>
-          <a:xfrm>
-            <a:off x="5223053" y="1965960"/>
-            <a:ext cx="2640787" cy="2974848"/>
-          </a:xfrm>
-          <a:prstGeom prst="roundRect">
-            <a:avLst>
-              <a:gd name="adj" fmla="val 2770"/>
-            </a:avLst>
-          </a:prstGeom>
-          <a:solidFill>
-            <a:srgbClr val="EEF6EE"/>
-          </a:solidFill>
-          <a:ln w="12700">
-            <a:solidFill>
-              <a:srgbClr val="2E7D32"/>
-            </a:solidFill>
-            <a:prstDash val="solid"/>
-          </a:ln>
-        </p:spPr>
-      </p:sp>
-      <p:sp>
-        <p:nvSpPr>
-          <p:cNvPr id="8" name="Text 6"/>
-          <p:cNvSpPr txBox="1"/>
-          <p:nvPr/>
-        </p:nvSpPr>
-        <p:spPr>
-          <a:xfrm>
-            <a:off x="5451653" y="2075688"/>
-            <a:ext cx="2183587" cy="274320"/>
-          </a:xfrm>
-          <a:prstGeom prst="rect">
-            <a:avLst/>
-          </a:prstGeom>
-          <a:noFill/>
-          <a:ln/>
-        </p:spPr>
-        <p:txBody>
-          <a:bodyPr wrap="square" lIns="0" tIns="0" rIns="0" bIns="0" rtlCol="0" anchor="ctr"/>
-          <a:lstStyle/>
-          <a:p>
-            <a:pPr indent="0" marL="0">
-              <a:buNone/>
-            </a:pPr>
-            <a:r>
-              <a:rPr lang="en-US" sz="1300" b="1" spc="200" kern="0" dirty="0">
-                <a:solidFill>
-                  <a:srgbClr val="2E7D32"/>
-                </a:solidFill>
-              </a:rPr>
-              <a:t>GESCHAFFT, WENN …</a:t>
-            </a:r>
-            <a:endParaRPr lang="en-US" sz="1300" dirty="0"/>
-          </a:p>
-        </p:txBody>
-      </p:sp>
-      <p:sp>
-        <p:nvSpPr>
-          <p:cNvPr id="9" name="Text 7"/>
-          <p:cNvSpPr txBox="1"/>
-          <p:nvPr/>
-        </p:nvSpPr>
-        <p:spPr>
-          <a:xfrm>
-            <a:off x="5451653" y="2423160"/>
-            <a:ext cx="2183587" cy="665480"/>
-          </a:xfrm>
-          <a:prstGeom prst="rect">
-            <a:avLst/>
-          </a:prstGeom>
-          <a:noFill/>
-          <a:ln/>
-        </p:spPr>
-        <p:txBody>
-          <a:bodyPr wrap="square" lIns="0" tIns="0" rIns="0" bIns="0" rtlCol="0" anchor="t"/>
-          <a:lstStyle/>
-          <a:p>
-            <a:pPr algn="l" indent="0" marL="0">
-              <a:buNone/>
-            </a:pPr>
-            <a:r>
-              <a:rPr lang="en-US" sz="2000" dirty="0">
-                <a:solidFill>
-                  <a:srgbClr val="1B1B1F"/>
-                </a:solidFill>
-              </a:rPr>
-              <a:t>dein Code im Heft steht</a:t>
-            </a:r>
-            <a:endParaRPr lang="en-US" sz="2000" dirty="0"/>
-          </a:p>
-        </p:txBody>
-      </p:sp>
-      <p:sp>
-        <p:nvSpPr>
-          <p:cNvPr id="10" name="Text 8"/>
-          <p:cNvSpPr txBox="1"/>
-          <p:nvPr/>
-        </p:nvSpPr>
-        <p:spPr>
-          <a:xfrm>
-            <a:off x="5451653" y="3216656"/>
-            <a:ext cx="2183587" cy="665480"/>
-          </a:xfrm>
-          <a:prstGeom prst="rect">
-            <a:avLst/>
-          </a:prstGeom>
-          <a:noFill/>
-          <a:ln/>
-        </p:spPr>
-        <p:txBody>
-          <a:bodyPr wrap="square" lIns="0" tIns="0" rIns="0" bIns="0" rtlCol="0" anchor="t"/>
-          <a:lstStyle/>
-          <a:p>
-            <a:pPr algn="l" indent="0" marL="0">
-              <a:buNone/>
-            </a:pPr>
-            <a:r>
-              <a:rPr lang="en-US" sz="2000" dirty="0">
-                <a:solidFill>
-                  <a:srgbClr val="1B1B1F"/>
-                </a:solidFill>
-              </a:rPr>
-              <a:t>du die Zeitleiste siehst</a:t>
-            </a:r>
-            <a:endParaRPr lang="en-US" sz="2000" dirty="0"/>
-          </a:p>
-        </p:txBody>
-      </p:sp>
-      <p:sp>
-        <p:nvSpPr>
-          <p:cNvPr id="11" name="Text 9"/>
-          <p:cNvSpPr txBox="1"/>
-          <p:nvPr/>
-        </p:nvSpPr>
-        <p:spPr>
-          <a:xfrm>
-            <a:off x="5451653" y="4010152"/>
-            <a:ext cx="2183587" cy="665480"/>
-          </a:xfrm>
-          <a:prstGeom prst="rect">
-            <a:avLst/>
-          </a:prstGeom>
-          <a:noFill/>
-          <a:ln/>
-        </p:spPr>
-        <p:txBody>
-          <a:bodyPr wrap="square" lIns="0" tIns="0" rIns="0" bIns="0" rtlCol="0" anchor="t"/>
-          <a:lstStyle/>
-          <a:p>
-            <a:pPr algn="l" indent="0" marL="0">
-              <a:buNone/>
-            </a:pPr>
-            <a:r>
-              <a:rPr lang="en-US" sz="2000" dirty="0">
-                <a:solidFill>
-                  <a:srgbClr val="1B1B1F"/>
-                </a:solidFill>
-              </a:rPr>
-              <a:t>die ersten Punkte da sind</a:t>
-            </a:r>
-            <a:endParaRPr lang="en-US" sz="2000" dirty="0"/>
           </a:p>
         </p:txBody>
       </p:sp>
@@ -4482,7 +4436,7 @@
                 <a:ea typeface="Georgia" pitchFamily="34" charset="-122"/>
                 <a:cs typeface="Georgia" pitchFamily="34" charset="-120"/>
               </a:rPr>
-              <a:t>Das nimmst du mit</a:t>
+              <a:t>Probier es aus!</a:t>
             </a:r>
             <a:endParaRPr lang="en-US" sz="3000" dirty="0"/>
           </a:p>
@@ -4490,26 +4444,224 @@
       </p:sp>
       <p:sp>
         <p:nvSpPr>
-          <p:cNvPr id="3" name="Merke-Kasten"/>
+          <p:cNvPr id="3" name="Text 1"/>
+          <p:cNvSpPr txBox="1"/>
+          <p:nvPr/>
+        </p:nvSpPr>
+        <p:spPr>
+          <a:xfrm>
+            <a:off x="548640" y="1325880"/>
+            <a:ext cx="1463040" cy="384048"/>
+          </a:xfrm>
+          <a:prstGeom prst="rect">
+            <a:avLst/>
+          </a:prstGeom>
+          <a:solidFill>
+            <a:srgbClr val="8A5F1A"/>
+          </a:solidFill>
+          <a:ln/>
+        </p:spPr>
+        <p:txBody>
+          <a:bodyPr wrap="square" lIns="0" tIns="0" rIns="0" bIns="0" rtlCol="0" anchor="ctr"/>
+          <a:lstStyle/>
+          <a:p>
+            <a:pPr algn="ctr" indent="0" marL="0">
+              <a:buNone/>
+            </a:pPr>
+            <a:r>
+              <a:rPr lang="en-US" sz="1400" b="1" spc="300" kern="0" dirty="0">
+                <a:solidFill>
+                  <a:srgbClr val="FFFFFF"/>
+                </a:solidFill>
+              </a:rPr>
+              <a:t>AUFTRAG</a:t>
+            </a:r>
+            <a:endParaRPr lang="en-US" sz="1400" dirty="0"/>
+          </a:p>
+        </p:txBody>
+      </p:sp>
+      <p:sp>
+        <p:nvSpPr>
+          <p:cNvPr id="4" name="Text 2"/>
+          <p:cNvSpPr txBox="1"/>
+          <p:nvPr/>
+        </p:nvSpPr>
+        <p:spPr>
+          <a:xfrm>
+            <a:off x="2148840" y="1325880"/>
+            <a:ext cx="2075688" cy="384048"/>
+          </a:xfrm>
+          <a:prstGeom prst="rect">
+            <a:avLst/>
+          </a:prstGeom>
+          <a:solidFill>
+            <a:srgbClr val="F2EADB"/>
+          </a:solidFill>
+          <a:ln/>
+        </p:spPr>
+        <p:txBody>
+          <a:bodyPr wrap="square" lIns="0" tIns="0" rIns="0" bIns="0" rtlCol="0" anchor="ctr"/>
+          <a:lstStyle/>
+          <a:p>
+            <a:pPr algn="ctr" indent="0" marL="0">
+              <a:buNone/>
+            </a:pPr>
+            <a:r>
+              <a:rPr lang="en-US" sz="1400" dirty="0">
+                <a:solidFill>
+                  <a:srgbClr val="1B1B1F"/>
+                </a:solidFill>
+              </a:rPr>
+              <a:t>⏸ Video anhalten</a:t>
+            </a:r>
+            <a:endParaRPr lang="en-US" sz="1400" dirty="0"/>
+          </a:p>
+        </p:txBody>
+      </p:sp>
+      <p:sp>
+        <p:nvSpPr>
+          <p:cNvPr id="5" name="Text 3"/>
+          <p:cNvSpPr txBox="1"/>
+          <p:nvPr/>
+        </p:nvSpPr>
+        <p:spPr>
+          <a:xfrm>
+            <a:off x="4361688" y="1325880"/>
+            <a:ext cx="2075688" cy="384048"/>
+          </a:xfrm>
+          <a:prstGeom prst="rect">
+            <a:avLst/>
+          </a:prstGeom>
+          <a:solidFill>
+            <a:srgbClr val="F2EADB"/>
+          </a:solidFill>
+          <a:ln/>
+        </p:spPr>
+        <p:txBody>
+          <a:bodyPr wrap="square" lIns="0" tIns="0" rIns="0" bIns="0" rtlCol="0" anchor="ctr"/>
+          <a:lstStyle/>
+          <a:p>
+            <a:pPr algn="ctr" indent="0" marL="0">
+              <a:buNone/>
+            </a:pPr>
+            <a:r>
+              <a:rPr lang="en-US" sz="1400" dirty="0">
+                <a:solidFill>
+                  <a:srgbClr val="1B1B1F"/>
+                </a:solidFill>
+              </a:rPr>
+              <a:t>selbst probieren</a:t>
+            </a:r>
+            <a:endParaRPr lang="en-US" sz="1400" dirty="0"/>
+          </a:p>
+        </p:txBody>
+      </p:sp>
+      <p:sp>
+        <p:nvSpPr>
+          <p:cNvPr id="6" name="Text 4"/>
+          <p:cNvSpPr txBox="1"/>
+          <p:nvPr/>
+        </p:nvSpPr>
+        <p:spPr>
+          <a:xfrm>
+            <a:off x="548640" y="1965960"/>
+            <a:ext cx="4308653" cy="2090928"/>
+          </a:xfrm>
+          <a:prstGeom prst="rect">
+            <a:avLst/>
+          </a:prstGeom>
+          <a:noFill/>
+          <a:ln/>
+        </p:spPr>
+        <p:txBody>
+          <a:bodyPr wrap="square" lIns="0" tIns="0" rIns="0" bIns="0" rtlCol="0" anchor="t"/>
+          <a:lstStyle/>
+          <a:p>
+            <a:pPr algn="l" indent="0" marL="0">
+              <a:buNone/>
+            </a:pPr>
+            <a:r>
+              <a:rPr lang="en-US" sz="2200" dirty="0">
+                <a:solidFill>
+                  <a:srgbClr val="1B1B1F"/>
+                </a:solidFill>
+              </a:rPr>
+              <a:t>Melde dich im Portal an und </a:t>
+            </a:r>
+            <a:r>
+              <a:rPr lang="en-US" sz="2200" b="1" dirty="0">
+                <a:solidFill>
+                  <a:srgbClr val="1B1B1F"/>
+                </a:solidFill>
+              </a:rPr>
+              <a:t>notiere deinen persönlichen Code</a:t>
+            </a:r>
+            <a:r>
+              <a:rPr lang="en-US" sz="2200" dirty="0">
+                <a:solidFill>
+                  <a:srgbClr val="1B1B1F"/>
+                </a:solidFill>
+              </a:rPr>
+              <a:t>. Wechsle mit „Weiter zu Kryptos“ in die Plattform, öffne die Epoche </a:t>
+            </a:r>
+            <a:r>
+              <a:rPr lang="en-US" sz="2200" b="1" dirty="0">
+                <a:solidFill>
+                  <a:srgbClr val="1B1B1F"/>
+                </a:solidFill>
+              </a:rPr>
+              <a:t>Antike</a:t>
+            </a:r>
+            <a:r>
+              <a:rPr lang="en-US" sz="2200" dirty="0">
+                <a:solidFill>
+                  <a:srgbClr val="1B1B1F"/>
+                </a:solidFill>
+              </a:rPr>
+              <a:t> und löse die erste Aufgabe in </a:t>
+            </a:r>
+            <a:r>
+              <a:rPr lang="en-US" sz="2200" b="1" dirty="0">
+                <a:solidFill>
+                  <a:srgbClr val="1B1B1F"/>
+                </a:solidFill>
+              </a:rPr>
+              <a:t>Level 0.1</a:t>
+            </a:r>
+            <a:r>
+              <a:rPr lang="en-US" sz="2200" dirty="0">
+                <a:solidFill>
+                  <a:srgbClr val="1B1B1F"/>
+                </a:solidFill>
+              </a:rPr>
+              <a:t>.</a:t>
+            </a:r>
+            <a:endParaRPr lang="en-US" sz="2200" dirty="0"/>
+          </a:p>
+        </p:txBody>
+      </p:sp>
+      <p:sp>
+        <p:nvSpPr>
+          <p:cNvPr id="7" name="Shape 5"/>
           <p:cNvSpPr/>
           <p:nvPr/>
         </p:nvSpPr>
         <p:spPr>
           <a:xfrm>
-            <a:off x="1097280" y="1508760"/>
-            <a:ext cx="6217920" cy="4663440"/>
+            <a:off x="5223053" y="1965960"/>
+            <a:ext cx="2640787" cy="2974848"/>
           </a:xfrm>
           <a:prstGeom prst="roundRect">
             <a:avLst>
-              <a:gd name="adj" fmla="val 1961"/>
+              <a:gd name="adj" fmla="val 2770"/>
             </a:avLst>
           </a:prstGeom>
           <a:solidFill>
-            <a:srgbClr val="FBF3E2"/>
+            <a:srgbClr val="EEF6EE"/>
           </a:solidFill>
-          <a:ln w="19050">
+          <a:ln w="12700">
             <a:solidFill>
-              <a:srgbClr val="B07D2B"/>
+              <a:srgbClr val="2E7D32"/>
             </a:solidFill>
             <a:prstDash val="solid"/>
           </a:ln>
@@ -4517,14 +4669,14 @@
       </p:sp>
       <p:sp>
         <p:nvSpPr>
-          <p:cNvPr id="4" name="Text 2"/>
+          <p:cNvPr id="8" name="Text 6"/>
           <p:cNvSpPr txBox="1"/>
           <p:nvPr/>
         </p:nvSpPr>
         <p:spPr>
           <a:xfrm>
-            <a:off x="1508760" y="1737360"/>
-            <a:ext cx="3657600" cy="411480"/>
+            <a:off x="5451653" y="2075688"/>
+            <a:ext cx="2183587" cy="274320"/>
           </a:xfrm>
           <a:prstGeom prst="rect">
             <a:avLst/>
@@ -4540,30 +4692,27 @@
               <a:buNone/>
             </a:pPr>
             <a:r>
-              <a:rPr lang="en-US" sz="2000" b="1" spc="400" kern="0" dirty="0">
-                <a:solidFill>
-                  <a:srgbClr val="8A5F1A"/>
-                </a:solidFill>
-                <a:latin typeface="Georgia" pitchFamily="34" charset="0"/>
-                <a:ea typeface="Georgia" pitchFamily="34" charset="-122"/>
-                <a:cs typeface="Georgia" pitchFamily="34" charset="-120"/>
-              </a:rPr>
-              <a:t>MERKE</a:t>
-            </a:r>
-            <a:endParaRPr lang="en-US" sz="2000" dirty="0"/>
-          </a:p>
-        </p:txBody>
-      </p:sp>
-      <p:sp>
-        <p:nvSpPr>
-          <p:cNvPr id="5" name="Text 3"/>
+              <a:rPr lang="en-US" sz="1300" b="1" spc="200" kern="0" dirty="0">
+                <a:solidFill>
+                  <a:srgbClr val="2E7D32"/>
+                </a:solidFill>
+              </a:rPr>
+              <a:t>GESCHAFFT, WENN …</a:t>
+            </a:r>
+            <a:endParaRPr lang="en-US" sz="1300" dirty="0"/>
+          </a:p>
+        </p:txBody>
+      </p:sp>
+      <p:sp>
+        <p:nvSpPr>
+          <p:cNvPr id="9" name="Text 7"/>
           <p:cNvSpPr txBox="1"/>
           <p:nvPr/>
         </p:nvSpPr>
         <p:spPr>
           <a:xfrm>
-            <a:off x="1508760" y="2240280"/>
-            <a:ext cx="5394960" cy="603504"/>
+            <a:off x="5451653" y="2423160"/>
+            <a:ext cx="2183587" cy="665480"/>
           </a:xfrm>
           <a:prstGeom prst="rect">
             <a:avLst/>
@@ -4579,51 +4728,27 @@
               <a:buNone/>
             </a:pPr>
             <a:r>
-              <a:rPr lang="en-US" sz="1800" dirty="0">
+              <a:rPr lang="en-US" sz="2000" dirty="0">
                 <a:solidFill>
                   <a:srgbClr val="1B1B1F"/>
                 </a:solidFill>
               </a:rPr>
-              <a:t>Anmelden immer über </a:t>
-            </a:r>
-            <a:r>
-              <a:rPr lang="en-US" sz="1800" b="1" dirty="0">
-                <a:solidFill>
-                  <a:srgbClr val="1B1B1F"/>
-                </a:solidFill>
-              </a:rPr>
-              <a:t>InfoLabs</a:t>
-            </a:r>
-            <a:r>
-              <a:rPr lang="en-US" sz="1800" dirty="0">
-                <a:solidFill>
-                  <a:srgbClr val="1B1B1F"/>
-                </a:solidFill>
-              </a:rPr>
-              <a:t>: einmal Kurscode + Name, danach </a:t>
-            </a:r>
-            <a:r>
-              <a:rPr lang="en-US" sz="1800" b="1" dirty="0">
-                <a:solidFill>
-                  <a:srgbClr val="1B1B1F"/>
-                </a:solidFill>
-              </a:rPr>
-              <a:t>Name + persönlicher Code</a:t>
-            </a:r>
-            <a:endParaRPr lang="en-US" sz="1800" dirty="0"/>
-          </a:p>
-        </p:txBody>
-      </p:sp>
-      <p:sp>
-        <p:nvSpPr>
-          <p:cNvPr id="6" name="Text 4"/>
+              <a:t>dein Code im Heft steht</a:t>
+            </a:r>
+            <a:endParaRPr lang="en-US" sz="2000" dirty="0"/>
+          </a:p>
+        </p:txBody>
+      </p:sp>
+      <p:sp>
+        <p:nvSpPr>
+          <p:cNvPr id="10" name="Text 8"/>
           <p:cNvSpPr txBox="1"/>
           <p:nvPr/>
         </p:nvSpPr>
         <p:spPr>
           <a:xfrm>
-            <a:off x="1508760" y="2971800"/>
-            <a:ext cx="5394960" cy="603504"/>
+            <a:off x="5451653" y="3216656"/>
+            <a:ext cx="2183587" cy="665480"/>
           </a:xfrm>
           <a:prstGeom prst="rect">
             <a:avLst/>
@@ -4639,43 +4764,27 @@
               <a:buNone/>
             </a:pPr>
             <a:r>
-              <a:rPr lang="en-US" sz="1800" dirty="0">
+              <a:rPr lang="en-US" sz="2000" dirty="0">
                 <a:solidFill>
                   <a:srgbClr val="1B1B1F"/>
                 </a:solidFill>
               </a:rPr>
-              <a:t>„</a:t>
-            </a:r>
-            <a:r>
-              <a:rPr lang="en-US" sz="1800" b="1" dirty="0">
-                <a:solidFill>
-                  <a:srgbClr val="1B1B1F"/>
-                </a:solidFill>
-              </a:rPr>
-              <a:t>Weiter zu Kryptos</a:t>
-            </a:r>
-            <a:r>
-              <a:rPr lang="en-US" sz="1800" dirty="0">
-                <a:solidFill>
-                  <a:srgbClr val="1B1B1F"/>
-                </a:solidFill>
-              </a:rPr>
-              <a:t>“ – kein eigenes Passwort; Code notieren und für dich behalten</a:t>
-            </a:r>
-            <a:endParaRPr lang="en-US" sz="1800" dirty="0"/>
-          </a:p>
-        </p:txBody>
-      </p:sp>
-      <p:sp>
-        <p:nvSpPr>
-          <p:cNvPr id="7" name="Text 5"/>
+              <a:t>du die Zeitleiste siehst</a:t>
+            </a:r>
+            <a:endParaRPr lang="en-US" sz="2000" dirty="0"/>
+          </a:p>
+        </p:txBody>
+      </p:sp>
+      <p:sp>
+        <p:nvSpPr>
+          <p:cNvPr id="11" name="Text 9"/>
           <p:cNvSpPr txBox="1"/>
           <p:nvPr/>
         </p:nvSpPr>
         <p:spPr>
           <a:xfrm>
-            <a:off x="1508760" y="3703320"/>
-            <a:ext cx="5394960" cy="882396"/>
+            <a:off x="5451653" y="4010152"/>
+            <a:ext cx="2183587" cy="665480"/>
           </a:xfrm>
           <a:prstGeom prst="rect">
             <a:avLst/>
@@ -4691,82 +4800,14 @@
               <a:buNone/>
             </a:pPr>
             <a:r>
-              <a:rPr lang="en-US" sz="1800" dirty="0">
+              <a:rPr lang="en-US" sz="2000" dirty="0">
                 <a:solidFill>
                   <a:srgbClr val="1B1B1F"/>
                 </a:solidFill>
               </a:rPr>
-              <a:t>Tipp − 20 %, Fehlversuch − 25 %, „Lösung zeigen“ 0 – die </a:t>
-            </a:r>
-            <a:r>
-              <a:rPr lang="en-US" sz="1800" b="1" dirty="0">
-                <a:solidFill>
-                  <a:srgbClr val="1B1B1F"/>
-                </a:solidFill>
-              </a:rPr>
-              <a:t>Fallen P1–P10</a:t>
-            </a:r>
-            <a:r>
-              <a:rPr lang="en-US" sz="1800" dirty="0">
-                <a:solidFill>
-                  <a:srgbClr val="1B1B1F"/>
-                </a:solidFill>
-              </a:rPr>
-              <a:t> zeigen deine Stolpersteine</a:t>
-            </a:r>
-            <a:endParaRPr lang="en-US" sz="1800" dirty="0"/>
-          </a:p>
-        </p:txBody>
-      </p:sp>
-      <p:sp>
-        <p:nvSpPr>
-          <p:cNvPr id="8" name="Text 6"/>
-          <p:cNvSpPr txBox="1"/>
-          <p:nvPr/>
-        </p:nvSpPr>
-        <p:spPr>
-          <a:xfrm>
-            <a:off x="1508760" y="4713732"/>
-            <a:ext cx="5394960" cy="603504"/>
-          </a:xfrm>
-          <a:prstGeom prst="rect">
-            <a:avLst/>
-          </a:prstGeom>
-          <a:noFill/>
-          <a:ln/>
-        </p:spPr>
-        <p:txBody>
-          <a:bodyPr wrap="square" lIns="0" tIns="0" rIns="0" bIns="0" rtlCol="0" anchor="t"/>
-          <a:lstStyle/>
-          <a:p>
-            <a:pPr algn="l" indent="0" marL="0">
-              <a:buNone/>
-            </a:pPr>
-            <a:r>
-              <a:rPr lang="en-US" sz="1800" dirty="0">
-                <a:solidFill>
-                  <a:srgbClr val="1B1B1F"/>
-                </a:solidFill>
-              </a:rPr>
-              <a:t>Jede Epoche: Level, Trainingsplatz, </a:t>
-            </a:r>
-            <a:r>
-              <a:rPr lang="en-US" sz="1800" b="1" dirty="0">
-                <a:solidFill>
-                  <a:srgbClr val="1B1B1F"/>
-                </a:solidFill>
-              </a:rPr>
-              <a:t>Boss</a:t>
-            </a:r>
-            <a:r>
-              <a:rPr lang="en-US" sz="1800" dirty="0">
-                <a:solidFill>
-                  <a:srgbClr val="1B1B1F"/>
-                </a:solidFill>
-              </a:rPr>
-              <a:t> – dazu Kryptolabor, Funkraum und Gastmodus</a:t>
-            </a:r>
-            <a:endParaRPr lang="en-US" sz="1800" dirty="0"/>
+              <a:t>die ersten Punkte da sind</a:t>
+            </a:r>
+            <a:endParaRPr lang="en-US" sz="2000" dirty="0"/>
           </a:p>
         </p:txBody>
       </p:sp>
@@ -4875,6 +4916,399 @@
                 <a:ea typeface="Georgia" pitchFamily="34" charset="-122"/>
                 <a:cs typeface="Georgia" pitchFamily="34" charset="-120"/>
               </a:rPr>
+              <a:t>Das nimmst du mit</a:t>
+            </a:r>
+            <a:endParaRPr lang="en-US" sz="3000" dirty="0"/>
+          </a:p>
+        </p:txBody>
+      </p:sp>
+      <p:sp>
+        <p:nvSpPr>
+          <p:cNvPr id="3" name="Merke-Kasten"/>
+          <p:cNvSpPr/>
+          <p:nvPr/>
+        </p:nvSpPr>
+        <p:spPr>
+          <a:xfrm>
+            <a:off x="1097280" y="1508760"/>
+            <a:ext cx="6217920" cy="4663440"/>
+          </a:xfrm>
+          <a:prstGeom prst="roundRect">
+            <a:avLst>
+              <a:gd name="adj" fmla="val 1961"/>
+            </a:avLst>
+          </a:prstGeom>
+          <a:solidFill>
+            <a:srgbClr val="FBF3E2"/>
+          </a:solidFill>
+          <a:ln w="19050">
+            <a:solidFill>
+              <a:srgbClr val="B07D2B"/>
+            </a:solidFill>
+            <a:prstDash val="solid"/>
+          </a:ln>
+        </p:spPr>
+      </p:sp>
+      <p:sp>
+        <p:nvSpPr>
+          <p:cNvPr id="4" name="Text 2"/>
+          <p:cNvSpPr txBox="1"/>
+          <p:nvPr/>
+        </p:nvSpPr>
+        <p:spPr>
+          <a:xfrm>
+            <a:off x="1508760" y="1737360"/>
+            <a:ext cx="3657600" cy="411480"/>
+          </a:xfrm>
+          <a:prstGeom prst="rect">
+            <a:avLst/>
+          </a:prstGeom>
+          <a:noFill/>
+          <a:ln/>
+        </p:spPr>
+        <p:txBody>
+          <a:bodyPr wrap="square" lIns="0" tIns="0" rIns="0" bIns="0" rtlCol="0" anchor="ctr"/>
+          <a:lstStyle/>
+          <a:p>
+            <a:pPr indent="0" marL="0">
+              <a:buNone/>
+            </a:pPr>
+            <a:r>
+              <a:rPr lang="en-US" sz="2000" b="1" spc="400" kern="0" dirty="0">
+                <a:solidFill>
+                  <a:srgbClr val="8A5F1A"/>
+                </a:solidFill>
+                <a:latin typeface="Georgia" pitchFamily="34" charset="0"/>
+                <a:ea typeface="Georgia" pitchFamily="34" charset="-122"/>
+                <a:cs typeface="Georgia" pitchFamily="34" charset="-120"/>
+              </a:rPr>
+              <a:t>MERKE</a:t>
+            </a:r>
+            <a:endParaRPr lang="en-US" sz="2000" dirty="0"/>
+          </a:p>
+        </p:txBody>
+      </p:sp>
+      <p:sp>
+        <p:nvSpPr>
+          <p:cNvPr id="5" name="Text 3"/>
+          <p:cNvSpPr txBox="1"/>
+          <p:nvPr/>
+        </p:nvSpPr>
+        <p:spPr>
+          <a:xfrm>
+            <a:off x="1508760" y="2240280"/>
+            <a:ext cx="5394960" cy="603504"/>
+          </a:xfrm>
+          <a:prstGeom prst="rect">
+            <a:avLst/>
+          </a:prstGeom>
+          <a:noFill/>
+          <a:ln/>
+        </p:spPr>
+        <p:txBody>
+          <a:bodyPr wrap="square" lIns="0" tIns="0" rIns="0" bIns="0" rtlCol="0" anchor="t"/>
+          <a:lstStyle/>
+          <a:p>
+            <a:pPr algn="l" indent="0" marL="0">
+              <a:buNone/>
+            </a:pPr>
+            <a:r>
+              <a:rPr lang="en-US" sz="1800" dirty="0">
+                <a:solidFill>
+                  <a:srgbClr val="1B1B1F"/>
+                </a:solidFill>
+              </a:rPr>
+              <a:t>Anmelden immer über </a:t>
+            </a:r>
+            <a:r>
+              <a:rPr lang="en-US" sz="1800" b="1" dirty="0">
+                <a:solidFill>
+                  <a:srgbClr val="1B1B1F"/>
+                </a:solidFill>
+              </a:rPr>
+              <a:t>InfoLabs</a:t>
+            </a:r>
+            <a:r>
+              <a:rPr lang="en-US" sz="1800" dirty="0">
+                <a:solidFill>
+                  <a:srgbClr val="1B1B1F"/>
+                </a:solidFill>
+              </a:rPr>
+              <a:t>: einmal Kurscode + Name, danach </a:t>
+            </a:r>
+            <a:r>
+              <a:rPr lang="en-US" sz="1800" b="1" dirty="0">
+                <a:solidFill>
+                  <a:srgbClr val="1B1B1F"/>
+                </a:solidFill>
+              </a:rPr>
+              <a:t>Name + persönlicher Code</a:t>
+            </a:r>
+            <a:endParaRPr lang="en-US" sz="1800" dirty="0"/>
+          </a:p>
+        </p:txBody>
+      </p:sp>
+      <p:sp>
+        <p:nvSpPr>
+          <p:cNvPr id="6" name="Text 4"/>
+          <p:cNvSpPr txBox="1"/>
+          <p:nvPr/>
+        </p:nvSpPr>
+        <p:spPr>
+          <a:xfrm>
+            <a:off x="1508760" y="2971800"/>
+            <a:ext cx="5394960" cy="603504"/>
+          </a:xfrm>
+          <a:prstGeom prst="rect">
+            <a:avLst/>
+          </a:prstGeom>
+          <a:noFill/>
+          <a:ln/>
+        </p:spPr>
+        <p:txBody>
+          <a:bodyPr wrap="square" lIns="0" tIns="0" rIns="0" bIns="0" rtlCol="0" anchor="t"/>
+          <a:lstStyle/>
+          <a:p>
+            <a:pPr algn="l" indent="0" marL="0">
+              <a:buNone/>
+            </a:pPr>
+            <a:r>
+              <a:rPr lang="en-US" sz="1800" dirty="0">
+                <a:solidFill>
+                  <a:srgbClr val="1B1B1F"/>
+                </a:solidFill>
+              </a:rPr>
+              <a:t>„</a:t>
+            </a:r>
+            <a:r>
+              <a:rPr lang="en-US" sz="1800" b="1" dirty="0">
+                <a:solidFill>
+                  <a:srgbClr val="1B1B1F"/>
+                </a:solidFill>
+              </a:rPr>
+              <a:t>Weiter zu Kryptos</a:t>
+            </a:r>
+            <a:r>
+              <a:rPr lang="en-US" sz="1800" dirty="0">
+                <a:solidFill>
+                  <a:srgbClr val="1B1B1F"/>
+                </a:solidFill>
+              </a:rPr>
+              <a:t>“ – kein eigenes Passwort; Code notieren und für dich behalten</a:t>
+            </a:r>
+            <a:endParaRPr lang="en-US" sz="1800" dirty="0"/>
+          </a:p>
+        </p:txBody>
+      </p:sp>
+      <p:sp>
+        <p:nvSpPr>
+          <p:cNvPr id="7" name="Text 5"/>
+          <p:cNvSpPr txBox="1"/>
+          <p:nvPr/>
+        </p:nvSpPr>
+        <p:spPr>
+          <a:xfrm>
+            <a:off x="1508760" y="3703320"/>
+            <a:ext cx="5394960" cy="882396"/>
+          </a:xfrm>
+          <a:prstGeom prst="rect">
+            <a:avLst/>
+          </a:prstGeom>
+          <a:noFill/>
+          <a:ln/>
+        </p:spPr>
+        <p:txBody>
+          <a:bodyPr wrap="square" lIns="0" tIns="0" rIns="0" bIns="0" rtlCol="0" anchor="t"/>
+          <a:lstStyle/>
+          <a:p>
+            <a:pPr algn="l" indent="0" marL="0">
+              <a:buNone/>
+            </a:pPr>
+            <a:r>
+              <a:rPr lang="en-US" sz="1800" dirty="0">
+                <a:solidFill>
+                  <a:srgbClr val="1B1B1F"/>
+                </a:solidFill>
+              </a:rPr>
+              <a:t>Tipp − 20 %, Fehlversuch − 25 %, „Lösung zeigen“ 0 – die </a:t>
+            </a:r>
+            <a:r>
+              <a:rPr lang="en-US" sz="1800" b="1" dirty="0">
+                <a:solidFill>
+                  <a:srgbClr val="1B1B1F"/>
+                </a:solidFill>
+              </a:rPr>
+              <a:t>Fallen P1–P10</a:t>
+            </a:r>
+            <a:r>
+              <a:rPr lang="en-US" sz="1800" dirty="0">
+                <a:solidFill>
+                  <a:srgbClr val="1B1B1F"/>
+                </a:solidFill>
+              </a:rPr>
+              <a:t> zeigen deine Stolpersteine</a:t>
+            </a:r>
+            <a:endParaRPr lang="en-US" sz="1800" dirty="0"/>
+          </a:p>
+        </p:txBody>
+      </p:sp>
+      <p:sp>
+        <p:nvSpPr>
+          <p:cNvPr id="8" name="Text 6"/>
+          <p:cNvSpPr txBox="1"/>
+          <p:nvPr/>
+        </p:nvSpPr>
+        <p:spPr>
+          <a:xfrm>
+            <a:off x="1508760" y="4713732"/>
+            <a:ext cx="5394960" cy="603504"/>
+          </a:xfrm>
+          <a:prstGeom prst="rect">
+            <a:avLst/>
+          </a:prstGeom>
+          <a:noFill/>
+          <a:ln/>
+        </p:spPr>
+        <p:txBody>
+          <a:bodyPr wrap="square" lIns="0" tIns="0" rIns="0" bIns="0" rtlCol="0" anchor="t"/>
+          <a:lstStyle/>
+          <a:p>
+            <a:pPr algn="l" indent="0" marL="0">
+              <a:buNone/>
+            </a:pPr>
+            <a:r>
+              <a:rPr lang="en-US" sz="1800" dirty="0">
+                <a:solidFill>
+                  <a:srgbClr val="1B1B1F"/>
+                </a:solidFill>
+              </a:rPr>
+              <a:t>Jede Epoche: Level, Trainingsplatz, </a:t>
+            </a:r>
+            <a:r>
+              <a:rPr lang="en-US" sz="1800" b="1" dirty="0">
+                <a:solidFill>
+                  <a:srgbClr val="1B1B1F"/>
+                </a:solidFill>
+              </a:rPr>
+              <a:t>Boss</a:t>
+            </a:r>
+            <a:r>
+              <a:rPr lang="en-US" sz="1800" dirty="0">
+                <a:solidFill>
+                  <a:srgbClr val="1B1B1F"/>
+                </a:solidFill>
+              </a:rPr>
+              <a:t> – dazu Kryptolabor, Funkraum und Gastmodus</a:t>
+            </a:r>
+            <a:endParaRPr lang="en-US" sz="1800" dirty="0"/>
+          </a:p>
+        </p:txBody>
+      </p:sp>
+      <p:sp>
+        <p:nvSpPr>
+          <p:cNvPr id="25" name="Slide Number Placeholder 0"/>
+          <p:cNvSpPr>
+            <a:spLocks noGrp="1"/>
+          </p:cNvSpPr>
+          <p:nvPr>
+            <p:ph type="sldNum" sz="quarter" idx="4294967295"/>
+          </p:nvPr>
+        </p:nvSpPr>
+        <p:spPr>
+          <a:xfrm>
+            <a:off x="11155680" y="6419088"/>
+            <a:ext cx="502920" cy="274320"/>
+          </a:xfrm>
+          <a:prstGeom prst="rect">
+            <a:avLst/>
+          </a:prstGeom>
+          <a:extLst>
+            <a:ext uri="{C572A759-6A51-4108-AA02-DFA0A04FC94B}">
+              <ma14:wrappingTextBoxFlag xmlns:ma14="http://schemas.microsoft.com/office/mac/drawingml/2011/main" val="0"/>
+            </a:ext>
+          </a:extLst>
+        </p:spPr>
+        <p:txBody>
+          <a:bodyPr/>
+          <a:lstStyle>
+            <a:lvl1pPr>
+              <a:defRPr sz="1000">
+                <a:solidFill>
+                  <a:srgbClr val="4A4A55"/>
+                </a:solidFill>
+              </a:defRPr>
+            </a:lvl1pPr>
+          </a:lstStyle>
+          <a:p>
+            <a:pPr algn="r"/>
+            <a:fld id="{F7021451-1387-4CA6-816F-3879F97B5CBC}" type="slidenum">
+              <a:rPr b="0" lang="en-US"/>
+              <a:t>15</a:t>
+            </a:fld>
+            <a:endParaRPr lang="en-US"/>
+          </a:p>
+        </p:txBody>
+      </p:sp>
+    </p:spTree>
+  </p:cSld>
+  <p:clrMapOvr>
+    <a:masterClrMapping/>
+  </p:clrMapOvr>
+</p:sld>
+</file>
+
+<file path=ppt/slides/slide16.xml><?xml version="1.0" encoding="utf-8"?>
+<p:sld xmlns:a="http://schemas.openxmlformats.org/drawingml/2006/main" xmlns:r="http://schemas.openxmlformats.org/officeDocument/2006/relationships" xmlns:p="http://schemas.openxmlformats.org/presentationml/2006/main">
+  <p:cSld name="Slide 16">
+    <p:spTree>
+      <p:nvGrpSpPr>
+        <p:cNvPr id="1" name=""/>
+        <p:cNvGrpSpPr/>
+        <p:nvPr/>
+      </p:nvGrpSpPr>
+      <p:grpSpPr>
+        <a:xfrm>
+          <a:off x="0" y="0"/>
+          <a:ext cx="0" cy="0"/>
+          <a:chOff x="0" y="0"/>
+          <a:chExt cx="0" cy="0"/>
+        </a:xfrm>
+      </p:grpSpPr>
+      <p:sp>
+        <p:nvSpPr>
+          <p:cNvPr id="2" name="Text 0"/>
+          <p:cNvSpPr/>
+          <p:nvPr>
+            <p:ph idx="101" type="title" hasCustomPrompt="1"/>
+          </p:nvPr>
+        </p:nvSpPr>
+        <p:spPr>
+          <a:xfrm>
+            <a:off x="1325880" y="347472"/>
+            <a:ext cx="10317175" cy="658368"/>
+          </a:xfrm>
+          <a:prstGeom prst="rect">
+            <a:avLst/>
+          </a:prstGeom>
+          <a:noFill/>
+          <a:ln/>
+        </p:spPr>
+        <p:txBody>
+          <a:bodyPr wrap="square" lIns="0" tIns="0" rIns="0" bIns="0" rtlCol="0" anchor="ctr"/>
+          <a:lstStyle/>
+          <a:p>
+            <a:pPr algn="l" indent="0" marL="0">
+              <a:buNone/>
+            </a:pPr>
+            <a:r>
+              <a:rPr lang="en-US" sz="3000" b="1" dirty="0">
+                <a:solidFill>
+                  <a:srgbClr val="14213D"/>
+                </a:solidFill>
+                <a:latin typeface="Georgia" pitchFamily="34" charset="0"/>
+                <a:ea typeface="Georgia" pitchFamily="34" charset="-122"/>
+                <a:cs typeface="Georgia" pitchFamily="34" charset="-120"/>
+              </a:rPr>
               <a:t>Weiter im Lab</a:t>
             </a:r>
             <a:endParaRPr lang="en-US" sz="3000" dirty="0"/>
@@ -4883,7 +5317,7 @@
       </p:sp>
       <p:graphicFrame>
         <p:nvGraphicFramePr>
-          <p:cNvPr id="16" name="Table 0"/>
+          <p:cNvPr id="17" name="Table 0"/>
           <p:cNvGraphicFramePr>
             <a:graphicFrameLocks noGrp="1"/>
           </p:cNvGraphicFramePr>
@@ -5546,7 +5980,7 @@
             <a:pPr algn="r"/>
             <a:fld id="{F7021451-1387-4CA6-816F-3879F97B5CBC}" type="slidenum">
               <a:rPr b="0" lang="en-US"/>
-              <a:t>15</a:t>
+              <a:t>16</a:t>
             </a:fld>
             <a:endParaRPr lang="en-US"/>
           </a:p>

</xml_diff>